<commit_message>
docs(deck): judge deck slide edits
Co-Authored-By: Claude Fable 5 <noreply@anthropic.com>
</commit_message>
<xml_diff>
--- a/docs/DECK.pptx
+++ b/docs/DECK.pptx
@@ -5,13 +5,13 @@
     <p:sldMasterId id="2147483648" r:id="rId1"/>
   </p:sldMasterIdLst>
   <p:sldIdLst>
-    <p:sldId id="256" r:id="rId7"/>
-    <p:sldId id="257" r:id="rId8"/>
-    <p:sldId id="258" r:id="rId9"/>
-    <p:sldId id="259" r:id="rId10"/>
-    <p:sldId id="260" r:id="rId11"/>
+    <p:sldId id="256" r:id="rId2"/>
+    <p:sldId id="257" r:id="rId3"/>
+    <p:sldId id="258" r:id="rId4"/>
+    <p:sldId id="259" r:id="rId5"/>
+    <p:sldId id="260" r:id="rId6"/>
   </p:sldIdLst>
-  <p:sldSz cx="12191695" cy="6858000" type="screen4x3"/>
+  <p:sldSz cx="12192000" cy="6858000"/>
   <p:notesSz cx="6858000" cy="9144000"/>
   <p:defaultTextStyle>
     <a:defPPr>
@@ -108,6 +108,22 @@
       </a:defRPr>
     </a:lvl9pPr>
   </p:defaultTextStyle>
+  <p:extLst>
+    <p:ext uri="{EFAFB233-063F-42B5-8137-9DF3F51BA10A}">
+      <p15:sldGuideLst xmlns:p15="http://schemas.microsoft.com/office/powerpoint/2012/main">
+        <p15:guide id="1" orient="horz" pos="2160">
+          <p15:clr>
+            <a:srgbClr val="A4A3A4"/>
+          </p15:clr>
+        </p15:guide>
+        <p15:guide id="2" pos="2880">
+          <p15:clr>
+            <a:srgbClr val="A4A3A4"/>
+          </p15:clr>
+        </p15:guide>
+      </p15:sldGuideLst>
+    </p:ext>
+  </p:extLst>
 </p:presentation>
 </file>
 
@@ -149,10 +165,9 @@
           <a:lstStyle/>
           <a:p>
             <a:r>
-              <a:rPr lang="en-US" smtClean="0"/>
+              <a:rPr lang="en-US"/>
               <a:t>Click to edit Master title style</a:t>
             </a:r>
-            <a:endParaRPr lang="en-US"/>
           </a:p>
         </p:txBody>
       </p:sp>
@@ -268,10 +283,9 @@
           </a:lstStyle>
           <a:p>
             <a:r>
-              <a:rPr lang="en-US" smtClean="0"/>
+              <a:rPr lang="en-US"/>
               <a:t>Click to edit Master subtitle style</a:t>
             </a:r>
-            <a:endParaRPr lang="en-US"/>
           </a:p>
         </p:txBody>
       </p:sp>
@@ -292,7 +306,7 @@
           <a:p>
             <a:fld id="{5BCAD085-E8A6-8845-BD4E-CB4CCA059FC4}" type="datetimeFigureOut">
               <a:rPr lang="en-US" smtClean="0"/>
-              <a:t>1/27/13</a:t>
+              <a:t>7/15/2026</a:t>
             </a:fld>
             <a:endParaRPr lang="en-US"/>
           </a:p>
@@ -386,10 +400,9 @@
           <a:lstStyle/>
           <a:p>
             <a:r>
-              <a:rPr lang="en-US" smtClean="0"/>
+              <a:rPr lang="en-US"/>
               <a:t>Click to edit Master title style</a:t>
             </a:r>
-            <a:endParaRPr lang="en-US"/>
           </a:p>
         </p:txBody>
       </p:sp>
@@ -410,38 +423,37 @@
           <a:p>
             <a:pPr lvl="0"/>
             <a:r>
-              <a:rPr lang="en-US" smtClean="0"/>
+              <a:rPr lang="en-US"/>
               <a:t>Click to edit Master text styles</a:t>
             </a:r>
           </a:p>
           <a:p>
             <a:pPr lvl="1"/>
             <a:r>
-              <a:rPr lang="en-US" smtClean="0"/>
+              <a:rPr lang="en-US"/>
               <a:t>Second level</a:t>
             </a:r>
           </a:p>
           <a:p>
             <a:pPr lvl="2"/>
             <a:r>
-              <a:rPr lang="en-US" smtClean="0"/>
+              <a:rPr lang="en-US"/>
               <a:t>Third level</a:t>
             </a:r>
           </a:p>
           <a:p>
             <a:pPr lvl="3"/>
             <a:r>
-              <a:rPr lang="en-US" smtClean="0"/>
+              <a:rPr lang="en-US"/>
               <a:t>Fourth level</a:t>
             </a:r>
           </a:p>
           <a:p>
             <a:pPr lvl="4"/>
             <a:r>
-              <a:rPr lang="en-US" smtClean="0"/>
+              <a:rPr lang="en-US"/>
               <a:t>Fifth level</a:t>
             </a:r>
-            <a:endParaRPr lang="en-US"/>
           </a:p>
         </p:txBody>
       </p:sp>
@@ -462,7 +474,7 @@
           <a:p>
             <a:fld id="{5BCAD085-E8A6-8845-BD4E-CB4CCA059FC4}" type="datetimeFigureOut">
               <a:rPr lang="en-US" smtClean="0"/>
-              <a:t>1/27/13</a:t>
+              <a:t>7/15/2026</a:t>
             </a:fld>
             <a:endParaRPr lang="en-US"/>
           </a:p>
@@ -561,10 +573,9 @@
           <a:lstStyle/>
           <a:p>
             <a:r>
-              <a:rPr lang="en-US" smtClean="0"/>
+              <a:rPr lang="en-US"/>
               <a:t>Click to edit Master title style</a:t>
             </a:r>
-            <a:endParaRPr lang="en-US"/>
           </a:p>
         </p:txBody>
       </p:sp>
@@ -590,38 +601,37 @@
           <a:p>
             <a:pPr lvl="0"/>
             <a:r>
-              <a:rPr lang="en-US" smtClean="0"/>
+              <a:rPr lang="en-US"/>
               <a:t>Click to edit Master text styles</a:t>
             </a:r>
           </a:p>
           <a:p>
             <a:pPr lvl="1"/>
             <a:r>
-              <a:rPr lang="en-US" smtClean="0"/>
+              <a:rPr lang="en-US"/>
               <a:t>Second level</a:t>
             </a:r>
           </a:p>
           <a:p>
             <a:pPr lvl="2"/>
             <a:r>
-              <a:rPr lang="en-US" smtClean="0"/>
+              <a:rPr lang="en-US"/>
               <a:t>Third level</a:t>
             </a:r>
           </a:p>
           <a:p>
             <a:pPr lvl="3"/>
             <a:r>
-              <a:rPr lang="en-US" smtClean="0"/>
+              <a:rPr lang="en-US"/>
               <a:t>Fourth level</a:t>
             </a:r>
           </a:p>
           <a:p>
             <a:pPr lvl="4"/>
             <a:r>
-              <a:rPr lang="en-US" smtClean="0"/>
+              <a:rPr lang="en-US"/>
               <a:t>Fifth level</a:t>
             </a:r>
-            <a:endParaRPr lang="en-US"/>
           </a:p>
         </p:txBody>
       </p:sp>
@@ -642,7 +652,7 @@
           <a:p>
             <a:fld id="{5BCAD085-E8A6-8845-BD4E-CB4CCA059FC4}" type="datetimeFigureOut">
               <a:rPr lang="en-US" smtClean="0"/>
-              <a:t>1/27/13</a:t>
+              <a:t>7/15/2026</a:t>
             </a:fld>
             <a:endParaRPr lang="en-US"/>
           </a:p>
@@ -736,10 +746,9 @@
           <a:lstStyle/>
           <a:p>
             <a:r>
-              <a:rPr lang="en-US" smtClean="0"/>
+              <a:rPr lang="en-US"/>
               <a:t>Click to edit Master title style</a:t>
             </a:r>
-            <a:endParaRPr lang="en-US"/>
           </a:p>
         </p:txBody>
       </p:sp>
@@ -760,38 +769,37 @@
           <a:p>
             <a:pPr lvl="0"/>
             <a:r>
-              <a:rPr lang="en-US" smtClean="0"/>
+              <a:rPr lang="en-US"/>
               <a:t>Click to edit Master text styles</a:t>
             </a:r>
           </a:p>
           <a:p>
             <a:pPr lvl="1"/>
             <a:r>
-              <a:rPr lang="en-US" smtClean="0"/>
+              <a:rPr lang="en-US"/>
               <a:t>Second level</a:t>
             </a:r>
           </a:p>
           <a:p>
             <a:pPr lvl="2"/>
             <a:r>
-              <a:rPr lang="en-US" smtClean="0"/>
+              <a:rPr lang="en-US"/>
               <a:t>Third level</a:t>
             </a:r>
           </a:p>
           <a:p>
             <a:pPr lvl="3"/>
             <a:r>
-              <a:rPr lang="en-US" smtClean="0"/>
+              <a:rPr lang="en-US"/>
               <a:t>Fourth level</a:t>
             </a:r>
           </a:p>
           <a:p>
             <a:pPr lvl="4"/>
             <a:r>
-              <a:rPr lang="en-US" smtClean="0"/>
+              <a:rPr lang="en-US"/>
               <a:t>Fifth level</a:t>
             </a:r>
-            <a:endParaRPr lang="en-US"/>
           </a:p>
         </p:txBody>
       </p:sp>
@@ -812,7 +820,7 @@
           <a:p>
             <a:fld id="{5BCAD085-E8A6-8845-BD4E-CB4CCA059FC4}" type="datetimeFigureOut">
               <a:rPr lang="en-US" smtClean="0"/>
-              <a:t>1/27/13</a:t>
+              <a:t>7/15/2026</a:t>
             </a:fld>
             <a:endParaRPr lang="en-US"/>
           </a:p>
@@ -915,10 +923,9 @@
           </a:lstStyle>
           <a:p>
             <a:r>
-              <a:rPr lang="en-US" smtClean="0"/>
+              <a:rPr lang="en-US"/>
               <a:t>Click to edit Master title style</a:t>
             </a:r>
-            <a:endParaRPr lang="en-US"/>
           </a:p>
         </p:txBody>
       </p:sp>
@@ -1035,7 +1042,7 @@
           <a:p>
             <a:pPr lvl="0"/>
             <a:r>
-              <a:rPr lang="en-US" smtClean="0"/>
+              <a:rPr lang="en-US"/>
               <a:t>Click to edit Master text styles</a:t>
             </a:r>
           </a:p>
@@ -1058,7 +1065,7 @@
           <a:p>
             <a:fld id="{5BCAD085-E8A6-8845-BD4E-CB4CCA059FC4}" type="datetimeFigureOut">
               <a:rPr lang="en-US" smtClean="0"/>
-              <a:t>1/27/13</a:t>
+              <a:t>7/15/2026</a:t>
             </a:fld>
             <a:endParaRPr lang="en-US"/>
           </a:p>
@@ -1152,10 +1159,9 @@
           <a:lstStyle/>
           <a:p>
             <a:r>
-              <a:rPr lang="en-US" smtClean="0"/>
+              <a:rPr lang="en-US"/>
               <a:t>Click to edit Master title style</a:t>
             </a:r>
-            <a:endParaRPr lang="en-US"/>
           </a:p>
         </p:txBody>
       </p:sp>
@@ -1209,38 +1215,37 @@
           <a:p>
             <a:pPr lvl="0"/>
             <a:r>
-              <a:rPr lang="en-US" smtClean="0"/>
+              <a:rPr lang="en-US"/>
               <a:t>Click to edit Master text styles</a:t>
             </a:r>
           </a:p>
           <a:p>
             <a:pPr lvl="1"/>
             <a:r>
-              <a:rPr lang="en-US" smtClean="0"/>
+              <a:rPr lang="en-US"/>
               <a:t>Second level</a:t>
             </a:r>
           </a:p>
           <a:p>
             <a:pPr lvl="2"/>
             <a:r>
-              <a:rPr lang="en-US" smtClean="0"/>
+              <a:rPr lang="en-US"/>
               <a:t>Third level</a:t>
             </a:r>
           </a:p>
           <a:p>
             <a:pPr lvl="3"/>
             <a:r>
-              <a:rPr lang="en-US" smtClean="0"/>
+              <a:rPr lang="en-US"/>
               <a:t>Fourth level</a:t>
             </a:r>
           </a:p>
           <a:p>
             <a:pPr lvl="4"/>
             <a:r>
-              <a:rPr lang="en-US" smtClean="0"/>
+              <a:rPr lang="en-US"/>
               <a:t>Fifth level</a:t>
             </a:r>
-            <a:endParaRPr lang="en-US"/>
           </a:p>
         </p:txBody>
       </p:sp>
@@ -1294,38 +1299,37 @@
           <a:p>
             <a:pPr lvl="0"/>
             <a:r>
-              <a:rPr lang="en-US" smtClean="0"/>
+              <a:rPr lang="en-US"/>
               <a:t>Click to edit Master text styles</a:t>
             </a:r>
           </a:p>
           <a:p>
             <a:pPr lvl="1"/>
             <a:r>
-              <a:rPr lang="en-US" smtClean="0"/>
+              <a:rPr lang="en-US"/>
               <a:t>Second level</a:t>
             </a:r>
           </a:p>
           <a:p>
             <a:pPr lvl="2"/>
             <a:r>
-              <a:rPr lang="en-US" smtClean="0"/>
+              <a:rPr lang="en-US"/>
               <a:t>Third level</a:t>
             </a:r>
           </a:p>
           <a:p>
             <a:pPr lvl="3"/>
             <a:r>
-              <a:rPr lang="en-US" smtClean="0"/>
+              <a:rPr lang="en-US"/>
               <a:t>Fourth level</a:t>
             </a:r>
           </a:p>
           <a:p>
             <a:pPr lvl="4"/>
             <a:r>
-              <a:rPr lang="en-US" smtClean="0"/>
+              <a:rPr lang="en-US"/>
               <a:t>Fifth level</a:t>
             </a:r>
-            <a:endParaRPr lang="en-US"/>
           </a:p>
         </p:txBody>
       </p:sp>
@@ -1346,7 +1350,7 @@
           <a:p>
             <a:fld id="{5BCAD085-E8A6-8845-BD4E-CB4CCA059FC4}" type="datetimeFigureOut">
               <a:rPr lang="en-US" smtClean="0"/>
-              <a:t>1/27/13</a:t>
+              <a:t>7/15/2026</a:t>
             </a:fld>
             <a:endParaRPr lang="en-US"/>
           </a:p>
@@ -1444,10 +1448,9 @@
           </a:lstStyle>
           <a:p>
             <a:r>
-              <a:rPr lang="en-US" smtClean="0"/>
+              <a:rPr lang="en-US"/>
               <a:t>Click to edit Master title style</a:t>
             </a:r>
-            <a:endParaRPr lang="en-US"/>
           </a:p>
         </p:txBody>
       </p:sp>
@@ -1510,7 +1513,7 @@
           <a:p>
             <a:pPr lvl="0"/>
             <a:r>
-              <a:rPr lang="en-US" smtClean="0"/>
+              <a:rPr lang="en-US"/>
               <a:t>Click to edit Master text styles</a:t>
             </a:r>
           </a:p>
@@ -1566,38 +1569,37 @@
           <a:p>
             <a:pPr lvl="0"/>
             <a:r>
-              <a:rPr lang="en-US" smtClean="0"/>
+              <a:rPr lang="en-US"/>
               <a:t>Click to edit Master text styles</a:t>
             </a:r>
           </a:p>
           <a:p>
             <a:pPr lvl="1"/>
             <a:r>
-              <a:rPr lang="en-US" smtClean="0"/>
+              <a:rPr lang="en-US"/>
               <a:t>Second level</a:t>
             </a:r>
           </a:p>
           <a:p>
             <a:pPr lvl="2"/>
             <a:r>
-              <a:rPr lang="en-US" smtClean="0"/>
+              <a:rPr lang="en-US"/>
               <a:t>Third level</a:t>
             </a:r>
           </a:p>
           <a:p>
             <a:pPr lvl="3"/>
             <a:r>
-              <a:rPr lang="en-US" smtClean="0"/>
+              <a:rPr lang="en-US"/>
               <a:t>Fourth level</a:t>
             </a:r>
           </a:p>
           <a:p>
             <a:pPr lvl="4"/>
             <a:r>
-              <a:rPr lang="en-US" smtClean="0"/>
+              <a:rPr lang="en-US"/>
               <a:t>Fifth level</a:t>
             </a:r>
-            <a:endParaRPr lang="en-US"/>
           </a:p>
         </p:txBody>
       </p:sp>
@@ -1660,7 +1662,7 @@
           <a:p>
             <a:pPr lvl="0"/>
             <a:r>
-              <a:rPr lang="en-US" smtClean="0"/>
+              <a:rPr lang="en-US"/>
               <a:t>Click to edit Master text styles</a:t>
             </a:r>
           </a:p>
@@ -1716,38 +1718,37 @@
           <a:p>
             <a:pPr lvl="0"/>
             <a:r>
-              <a:rPr lang="en-US" smtClean="0"/>
+              <a:rPr lang="en-US"/>
               <a:t>Click to edit Master text styles</a:t>
             </a:r>
           </a:p>
           <a:p>
             <a:pPr lvl="1"/>
             <a:r>
-              <a:rPr lang="en-US" smtClean="0"/>
+              <a:rPr lang="en-US"/>
               <a:t>Second level</a:t>
             </a:r>
           </a:p>
           <a:p>
             <a:pPr lvl="2"/>
             <a:r>
-              <a:rPr lang="en-US" smtClean="0"/>
+              <a:rPr lang="en-US"/>
               <a:t>Third level</a:t>
             </a:r>
           </a:p>
           <a:p>
             <a:pPr lvl="3"/>
             <a:r>
-              <a:rPr lang="en-US" smtClean="0"/>
+              <a:rPr lang="en-US"/>
               <a:t>Fourth level</a:t>
             </a:r>
           </a:p>
           <a:p>
             <a:pPr lvl="4"/>
             <a:r>
-              <a:rPr lang="en-US" smtClean="0"/>
+              <a:rPr lang="en-US"/>
               <a:t>Fifth level</a:t>
             </a:r>
-            <a:endParaRPr lang="en-US"/>
           </a:p>
         </p:txBody>
       </p:sp>
@@ -1768,7 +1769,7 @@
           <a:p>
             <a:fld id="{5BCAD085-E8A6-8845-BD4E-CB4CCA059FC4}" type="datetimeFigureOut">
               <a:rPr lang="en-US" smtClean="0"/>
-              <a:t>1/27/13</a:t>
+              <a:t>7/15/2026</a:t>
             </a:fld>
             <a:endParaRPr lang="en-US"/>
           </a:p>
@@ -1862,10 +1863,9 @@
           <a:lstStyle/>
           <a:p>
             <a:r>
-              <a:rPr lang="en-US" smtClean="0"/>
+              <a:rPr lang="en-US"/>
               <a:t>Click to edit Master title style</a:t>
             </a:r>
-            <a:endParaRPr lang="en-US"/>
           </a:p>
         </p:txBody>
       </p:sp>
@@ -1886,7 +1886,7 @@
           <a:p>
             <a:fld id="{5BCAD085-E8A6-8845-BD4E-CB4CCA059FC4}" type="datetimeFigureOut">
               <a:rPr lang="en-US" smtClean="0"/>
-              <a:t>1/27/13</a:t>
+              <a:t>7/15/2026</a:t>
             </a:fld>
             <a:endParaRPr lang="en-US"/>
           </a:p>
@@ -1981,7 +1981,7 @@
           <a:p>
             <a:fld id="{5BCAD085-E8A6-8845-BD4E-CB4CCA059FC4}" type="datetimeFigureOut">
               <a:rPr lang="en-US" smtClean="0"/>
-              <a:t>1/27/13</a:t>
+              <a:t>7/15/2026</a:t>
             </a:fld>
             <a:endParaRPr lang="en-US"/>
           </a:p>
@@ -2084,10 +2084,9 @@
           </a:lstStyle>
           <a:p>
             <a:r>
-              <a:rPr lang="en-US" smtClean="0"/>
+              <a:rPr lang="en-US"/>
               <a:t>Click to edit Master title style</a:t>
             </a:r>
-            <a:endParaRPr lang="en-US"/>
           </a:p>
         </p:txBody>
       </p:sp>
@@ -2141,38 +2140,37 @@
           <a:p>
             <a:pPr lvl="0"/>
             <a:r>
-              <a:rPr lang="en-US" smtClean="0"/>
+              <a:rPr lang="en-US"/>
               <a:t>Click to edit Master text styles</a:t>
             </a:r>
           </a:p>
           <a:p>
             <a:pPr lvl="1"/>
             <a:r>
-              <a:rPr lang="en-US" smtClean="0"/>
+              <a:rPr lang="en-US"/>
               <a:t>Second level</a:t>
             </a:r>
           </a:p>
           <a:p>
             <a:pPr lvl="2"/>
             <a:r>
-              <a:rPr lang="en-US" smtClean="0"/>
+              <a:rPr lang="en-US"/>
               <a:t>Third level</a:t>
             </a:r>
           </a:p>
           <a:p>
             <a:pPr lvl="3"/>
             <a:r>
-              <a:rPr lang="en-US" smtClean="0"/>
+              <a:rPr lang="en-US"/>
               <a:t>Fourth level</a:t>
             </a:r>
           </a:p>
           <a:p>
             <a:pPr lvl="4"/>
             <a:r>
-              <a:rPr lang="en-US" smtClean="0"/>
+              <a:rPr lang="en-US"/>
               <a:t>Fifth level</a:t>
             </a:r>
-            <a:endParaRPr lang="en-US"/>
           </a:p>
         </p:txBody>
       </p:sp>
@@ -2235,7 +2233,7 @@
           <a:p>
             <a:pPr lvl="0"/>
             <a:r>
-              <a:rPr lang="en-US" smtClean="0"/>
+              <a:rPr lang="en-US"/>
               <a:t>Click to edit Master text styles</a:t>
             </a:r>
           </a:p>
@@ -2258,7 +2256,7 @@
           <a:p>
             <a:fld id="{5BCAD085-E8A6-8845-BD4E-CB4CCA059FC4}" type="datetimeFigureOut">
               <a:rPr lang="en-US" smtClean="0"/>
-              <a:t>1/27/13</a:t>
+              <a:t>7/15/2026</a:t>
             </a:fld>
             <a:endParaRPr lang="en-US"/>
           </a:p>
@@ -2361,10 +2359,9 @@
           </a:lstStyle>
           <a:p>
             <a:r>
-              <a:rPr lang="en-US" smtClean="0"/>
+              <a:rPr lang="en-US"/>
               <a:t>Click to edit Master title style</a:t>
             </a:r>
-            <a:endParaRPr lang="en-US"/>
           </a:p>
         </p:txBody>
       </p:sp>
@@ -2488,7 +2485,7 @@
           <a:p>
             <a:pPr lvl="0"/>
             <a:r>
-              <a:rPr lang="en-US" smtClean="0"/>
+              <a:rPr lang="en-US"/>
               <a:t>Click to edit Master text styles</a:t>
             </a:r>
           </a:p>
@@ -2511,7 +2508,7 @@
           <a:p>
             <a:fld id="{5BCAD085-E8A6-8845-BD4E-CB4CCA059FC4}" type="datetimeFigureOut">
               <a:rPr lang="en-US" smtClean="0"/>
-              <a:t>1/27/13</a:t>
+              <a:t>7/15/2026</a:t>
             </a:fld>
             <a:endParaRPr lang="en-US"/>
           </a:p>
@@ -2620,10 +2617,9 @@
           <a:lstStyle/>
           <a:p>
             <a:r>
-              <a:rPr lang="en-US" smtClean="0"/>
+              <a:rPr lang="en-US"/>
               <a:t>Click to edit Master title style</a:t>
             </a:r>
-            <a:endParaRPr lang="en-US"/>
           </a:p>
         </p:txBody>
       </p:sp>
@@ -2654,38 +2650,37 @@
           <a:p>
             <a:pPr lvl="0"/>
             <a:r>
-              <a:rPr lang="en-US" smtClean="0"/>
+              <a:rPr lang="en-US"/>
               <a:t>Click to edit Master text styles</a:t>
             </a:r>
           </a:p>
           <a:p>
             <a:pPr lvl="1"/>
             <a:r>
-              <a:rPr lang="en-US" smtClean="0"/>
+              <a:rPr lang="en-US"/>
               <a:t>Second level</a:t>
             </a:r>
           </a:p>
           <a:p>
             <a:pPr lvl="2"/>
             <a:r>
-              <a:rPr lang="en-US" smtClean="0"/>
+              <a:rPr lang="en-US"/>
               <a:t>Third level</a:t>
             </a:r>
           </a:p>
           <a:p>
             <a:pPr lvl="3"/>
             <a:r>
-              <a:rPr lang="en-US" smtClean="0"/>
+              <a:rPr lang="en-US"/>
               <a:t>Fourth level</a:t>
             </a:r>
           </a:p>
           <a:p>
             <a:pPr lvl="4"/>
             <a:r>
-              <a:rPr lang="en-US" smtClean="0"/>
+              <a:rPr lang="en-US"/>
               <a:t>Fifth level</a:t>
             </a:r>
-            <a:endParaRPr lang="en-US"/>
           </a:p>
         </p:txBody>
       </p:sp>
@@ -2724,7 +2719,7 @@
           <a:p>
             <a:fld id="{5BCAD085-E8A6-8845-BD4E-CB4CCA059FC4}" type="datetimeFigureOut">
               <a:rPr lang="en-US" smtClean="0"/>
-              <a:t>1/27/13</a:t>
+              <a:t>7/15/2026</a:t>
             </a:fld>
             <a:endParaRPr lang="en-US"/>
           </a:p>
@@ -2805,6 +2800,54 @@
               <a:t>‹#›</a:t>
             </a:fld>
             <a:endParaRPr lang="en-US"/>
+          </a:p>
+        </p:txBody>
+      </p:sp>
+      <p:sp>
+        <p:nvSpPr>
+          <p:cNvPr id="8" name="TextBox 7">
+            <a:extLst>
+              <a:ext uri="{FF2B5EF4-FFF2-40B4-BE49-F238E27FC236}">
+                <a16:creationId xmlns:a16="http://schemas.microsoft.com/office/drawing/2014/main" id="{3FB12F1E-D5CD-1AAA-4244-BC7928445427}"/>
+              </a:ext>
+            </a:extLst>
+          </p:cNvPr>
+          <p:cNvSpPr txBox="1"/>
+          <p:nvPr userDrawn="1">
+            <p:extLst>
+              <p:ext uri="{1162E1C5-73C7-4A58-AE30-91384D911F3F}">
+                <p184:classification xmlns:p184="http://schemas.microsoft.com/office/powerpoint/2018/4/main" val="hdr"/>
+              </p:ext>
+            </p:extLst>
+          </p:nvPr>
+        </p:nvSpPr>
+        <p:spPr>
+          <a:xfrm>
+            <a:off x="63500" y="63500"/>
+            <a:ext cx="581025" cy="152400"/>
+          </a:xfrm>
+          <a:prstGeom prst="rect">
+            <a:avLst/>
+          </a:prstGeom>
+        </p:spPr>
+        <p:txBody>
+          <a:bodyPr horzOverflow="overflow" lIns="0" tIns="0" rIns="0" bIns="0">
+            <a:spAutoFit/>
+          </a:bodyPr>
+          <a:lstStyle/>
+          <a:p>
+            <a:pPr algn="l"/>
+            <a:r>
+              <a:rPr lang="en-US" sz="1000">
+                <a:solidFill>
+                  <a:srgbClr val="0000FF">
+                    <a:alpha val="50000"/>
+                  </a:srgbClr>
+                </a:solidFill>
+                <a:latin typeface="Aptos" panose="020B0004020202020204" pitchFamily="34" charset="0"/>
+              </a:rPr>
+              <a:t>INTERNAL</a:t>
+            </a:r>
           </a:p>
         </p:txBody>
       </p:sp>
@@ -3083,7 +3126,7 @@
 </file>
 
 <file path=ppt/slides/slide1.xml><?xml version="1.0" encoding="utf-8"?>
-<p:sld xmlns:a="http://schemas.openxmlformats.org/drawingml/2006/main" xmlns:p="http://schemas.openxmlformats.org/presentationml/2006/main" xmlns:r="http://schemas.openxmlformats.org/officeDocument/2006/relationships">
+<p:sld xmlns:a="http://schemas.openxmlformats.org/drawingml/2006/main" xmlns:r="http://schemas.openxmlformats.org/officeDocument/2006/relationships" xmlns:p="http://schemas.openxmlformats.org/presentationml/2006/main">
   <p:cSld>
     <p:spTree>
       <p:nvGrpSpPr>
@@ -3091,7 +3134,14 @@
         <p:cNvGrpSpPr/>
         <p:nvPr/>
       </p:nvGrpSpPr>
-      <p:grpSpPr/>
+      <p:grpSpPr>
+        <a:xfrm>
+          <a:off x="0" y="0"/>
+          <a:ext cx="0" cy="0"/>
+          <a:chOff x="0" y="0"/>
+          <a:chExt cx="0" cy="0"/>
+        </a:xfrm>
+      </p:grpSpPr>
       <p:sp>
         <p:nvSpPr>
           <p:cNvPr id="2" name="Rectangle 1"/>
@@ -3132,6 +3182,7 @@
           <a:lstStyle/>
           <a:p>
             <a:pPr algn="ctr"/>
+            <a:endParaRPr/>
           </a:p>
         </p:txBody>
       </p:sp>
@@ -3210,7 +3261,7 @@
         <p:spPr>
           <a:xfrm>
             <a:off x="640080" y="1920240"/>
-            <a:ext cx="10881360" cy="4480560"/>
+            <a:ext cx="10881360" cy="2092881"/>
           </a:xfrm>
           <a:prstGeom prst="rect">
             <a:avLst/>
@@ -3229,13 +3280,26 @@
               </a:spcAft>
             </a:pPr>
             <a:r>
-              <a:rPr sz="1900" b="0">
+              <a:rPr sz="1900" b="0" dirty="0">
                 <a:solidFill>
                   <a:srgbClr val="222838"/>
                 </a:solidFill>
               </a:rPr>
-              <a:t>•  ServiceNow costs ~$300k/year — and every workflow change is a consulting engagement on top</a:t>
-            </a:r>
+              <a:t>•  ServiceNow costs ~$300k/year — and every workflow change </a:t>
+            </a:r>
+            <a:r>
+              <a:rPr lang="en-US" sz="1900" b="0" dirty="0">
+                <a:solidFill>
+                  <a:srgbClr val="222838"/>
+                </a:solidFill>
+              </a:rPr>
+              <a:t>requires a lot of human effort</a:t>
+            </a:r>
+            <a:endParaRPr sz="1900" b="0" dirty="0">
+              <a:solidFill>
+                <a:srgbClr val="222838"/>
+              </a:solidFill>
+            </a:endParaRPr>
           </a:p>
           <a:p>
             <a:pPr>
@@ -3244,13 +3308,26 @@
               </a:spcAft>
             </a:pPr>
             <a:r>
-              <a:rPr sz="1900" b="0">
+              <a:rPr sz="1900" b="0" dirty="0">
                 <a:solidFill>
                   <a:srgbClr val="222838"/>
                 </a:solidFill>
               </a:rPr>
               <a:t>•  Agents spend their time ROUTING tickets, not fixing them: manual categorization, priority guessing, the Service Desk relay</a:t>
             </a:r>
+            <a:r>
+              <a:rPr lang="en-US" sz="1900" b="0" dirty="0">
+                <a:solidFill>
+                  <a:srgbClr val="222838"/>
+                </a:solidFill>
+              </a:rPr>
+              <a:t> to other departments</a:t>
+            </a:r>
+            <a:endParaRPr sz="1900" b="0" dirty="0">
+              <a:solidFill>
+                <a:srgbClr val="222838"/>
+              </a:solidFill>
+            </a:endParaRPr>
           </a:p>
           <a:p>
             <a:pPr>
@@ -3259,7 +3336,7 @@
               </a:spcAft>
             </a:pPr>
             <a:r>
-              <a:rPr sz="1900" b="0">
+              <a:rPr sz="1900" b="0" dirty="0">
                 <a:solidFill>
                   <a:srgbClr val="222838"/>
                 </a:solidFill>
@@ -3274,7 +3351,7 @@
               </a:spcAft>
             </a:pPr>
             <a:r>
-              <a:rPr sz="1900" b="1">
+              <a:rPr sz="1900" b="1" dirty="0">
                 <a:solidFill>
                   <a:srgbClr val="16213A"/>
                 </a:solidFill>
@@ -3326,7 +3403,7 @@
 </file>
 
 <file path=ppt/slides/slide2.xml><?xml version="1.0" encoding="utf-8"?>
-<p:sld xmlns:a="http://schemas.openxmlformats.org/drawingml/2006/main" xmlns:p="http://schemas.openxmlformats.org/presentationml/2006/main" xmlns:r="http://schemas.openxmlformats.org/officeDocument/2006/relationships">
+<p:sld xmlns:a="http://schemas.openxmlformats.org/drawingml/2006/main" xmlns:r="http://schemas.openxmlformats.org/officeDocument/2006/relationships" xmlns:p="http://schemas.openxmlformats.org/presentationml/2006/main">
   <p:cSld>
     <p:spTree>
       <p:nvGrpSpPr>
@@ -3334,7 +3411,14 @@
         <p:cNvGrpSpPr/>
         <p:nvPr/>
       </p:nvGrpSpPr>
-      <p:grpSpPr/>
+      <p:grpSpPr>
+        <a:xfrm>
+          <a:off x="0" y="0"/>
+          <a:ext cx="0" cy="0"/>
+          <a:chOff x="0" y="0"/>
+          <a:chExt cx="0" cy="0"/>
+        </a:xfrm>
+      </p:grpSpPr>
       <p:sp>
         <p:nvSpPr>
           <p:cNvPr id="2" name="Rectangle 1"/>
@@ -3375,6 +3459,7 @@
           <a:lstStyle/>
           <a:p>
             <a:pPr algn="ctr"/>
+            <a:endParaRPr/>
           </a:p>
         </p:txBody>
       </p:sp>
@@ -3453,7 +3538,7 @@
         <p:spPr>
           <a:xfrm>
             <a:off x="640080" y="1920240"/>
-            <a:ext cx="10881360" cy="4480560"/>
+            <a:ext cx="10881360" cy="3149580"/>
           </a:xfrm>
           <a:prstGeom prst="rect">
             <a:avLst/>
@@ -3472,13 +3557,42 @@
               </a:spcAft>
             </a:pPr>
             <a:r>
-              <a:rPr sz="1900" b="0">
+              <a:rPr sz="1900" b="0" dirty="0">
                 <a:solidFill>
                   <a:srgbClr val="222838"/>
                 </a:solidFill>
               </a:rPr>
-              <a:t>•  METS — built in one week, solo, with Claude Code. AI-native, not AI-bolted-on</a:t>
-            </a:r>
+              <a:t>•  METS </a:t>
+            </a:r>
+            <a:r>
+              <a:rPr lang="en-US" sz="1900" b="0" dirty="0">
+                <a:solidFill>
+                  <a:srgbClr val="222838"/>
+                </a:solidFill>
+              </a:rPr>
+              <a:t>(Master Electronics Ticketing System)</a:t>
+            </a:r>
+            <a:r>
+              <a:rPr sz="1900" b="0" dirty="0">
+                <a:solidFill>
+                  <a:srgbClr val="222838"/>
+                </a:solidFill>
+              </a:rPr>
+              <a:t>— built in one week, solo, with Claude Code. AI-native, not AI-bolted-on</a:t>
+            </a:r>
+            <a:r>
+              <a:rPr lang="en-US" sz="1900" b="0" dirty="0">
+                <a:solidFill>
+                  <a:srgbClr val="222838"/>
+                </a:solidFill>
+              </a:rPr>
+              <a:t>.</a:t>
+            </a:r>
+            <a:endParaRPr sz="1900" b="0" dirty="0">
+              <a:solidFill>
+                <a:srgbClr val="222838"/>
+              </a:solidFill>
+            </a:endParaRPr>
           </a:p>
           <a:p>
             <a:pPr>
@@ -3487,7 +3601,7 @@
               </a:spcAft>
             </a:pPr>
             <a:r>
-              <a:rPr sz="1900" b="1">
+              <a:rPr sz="1900" b="1" dirty="0">
                 <a:solidFill>
                   <a:srgbClr val="16213A"/>
                 </a:solidFill>
@@ -3502,7 +3616,7 @@
               </a:spcAft>
             </a:pPr>
             <a:r>
-              <a:rPr sz="1900" b="0">
+              <a:rPr sz="1900" b="0" dirty="0">
                 <a:solidFill>
                   <a:srgbClr val="222838"/>
                 </a:solidFill>
@@ -3517,7 +3631,7 @@
               </a:spcAft>
             </a:pPr>
             <a:r>
-              <a:rPr sz="1900" b="0">
+              <a:rPr sz="1900" b="0" dirty="0">
                 <a:solidFill>
                   <a:srgbClr val="222838"/>
                 </a:solidFill>
@@ -3532,7 +3646,7 @@
               </a:spcAft>
             </a:pPr>
             <a:r>
-              <a:rPr sz="1900" b="0">
+              <a:rPr sz="1900" b="0" dirty="0">
                 <a:solidFill>
                   <a:srgbClr val="222838"/>
                 </a:solidFill>
@@ -3584,7 +3698,7 @@
 </file>
 
 <file path=ppt/slides/slide3.xml><?xml version="1.0" encoding="utf-8"?>
-<p:sld xmlns:a="http://schemas.openxmlformats.org/drawingml/2006/main" xmlns:p="http://schemas.openxmlformats.org/presentationml/2006/main" xmlns:r="http://schemas.openxmlformats.org/officeDocument/2006/relationships">
+<p:sld xmlns:a="http://schemas.openxmlformats.org/drawingml/2006/main" xmlns:r="http://schemas.openxmlformats.org/officeDocument/2006/relationships" xmlns:p="http://schemas.openxmlformats.org/presentationml/2006/main">
   <p:cSld>
     <p:spTree>
       <p:nvGrpSpPr>
@@ -3592,7 +3706,14 @@
         <p:cNvGrpSpPr/>
         <p:nvPr/>
       </p:nvGrpSpPr>
-      <p:grpSpPr/>
+      <p:grpSpPr>
+        <a:xfrm>
+          <a:off x="0" y="0"/>
+          <a:ext cx="0" cy="0"/>
+          <a:chOff x="0" y="0"/>
+          <a:chExt cx="0" cy="0"/>
+        </a:xfrm>
+      </p:grpSpPr>
       <p:sp>
         <p:nvSpPr>
           <p:cNvPr id="2" name="Rectangle 1"/>
@@ -3633,6 +3754,7 @@
           <a:lstStyle/>
           <a:p>
             <a:pPr algn="ctr"/>
+            <a:endParaRPr/>
           </a:p>
         </p:txBody>
       </p:sp>
@@ -3842,7 +3964,7 @@
 </file>
 
 <file path=ppt/slides/slide4.xml><?xml version="1.0" encoding="utf-8"?>
-<p:sld xmlns:a="http://schemas.openxmlformats.org/drawingml/2006/main" xmlns:p="http://schemas.openxmlformats.org/presentationml/2006/main" xmlns:r="http://schemas.openxmlformats.org/officeDocument/2006/relationships">
+<p:sld xmlns:a="http://schemas.openxmlformats.org/drawingml/2006/main" xmlns:r="http://schemas.openxmlformats.org/officeDocument/2006/relationships" xmlns:p="http://schemas.openxmlformats.org/presentationml/2006/main">
   <p:cSld>
     <p:spTree>
       <p:nvGrpSpPr>
@@ -3850,7 +3972,14 @@
         <p:cNvGrpSpPr/>
         <p:nvPr/>
       </p:nvGrpSpPr>
-      <p:grpSpPr/>
+      <p:grpSpPr>
+        <a:xfrm>
+          <a:off x="0" y="0"/>
+          <a:ext cx="0" cy="0"/>
+          <a:chOff x="0" y="0"/>
+          <a:chExt cx="0" cy="0"/>
+        </a:xfrm>
+      </p:grpSpPr>
       <p:sp>
         <p:nvSpPr>
           <p:cNvPr id="2" name="Rectangle 1"/>
@@ -3891,6 +4020,7 @@
           <a:lstStyle/>
           <a:p>
             <a:pPr algn="ctr"/>
+            <a:endParaRPr/>
           </a:p>
         </p:txBody>
       </p:sp>
@@ -4100,7 +4230,7 @@
 </file>
 
 <file path=ppt/slides/slide5.xml><?xml version="1.0" encoding="utf-8"?>
-<p:sld xmlns:a="http://schemas.openxmlformats.org/drawingml/2006/main" xmlns:p="http://schemas.openxmlformats.org/presentationml/2006/main" xmlns:r="http://schemas.openxmlformats.org/officeDocument/2006/relationships">
+<p:sld xmlns:a="http://schemas.openxmlformats.org/drawingml/2006/main" xmlns:r="http://schemas.openxmlformats.org/officeDocument/2006/relationships" xmlns:p="http://schemas.openxmlformats.org/presentationml/2006/main">
   <p:cSld>
     <p:spTree>
       <p:nvGrpSpPr>
@@ -4108,7 +4238,14 @@
         <p:cNvGrpSpPr/>
         <p:nvPr/>
       </p:nvGrpSpPr>
-      <p:grpSpPr/>
+      <p:grpSpPr>
+        <a:xfrm>
+          <a:off x="0" y="0"/>
+          <a:ext cx="0" cy="0"/>
+          <a:chOff x="0" y="0"/>
+          <a:chExt cx="0" cy="0"/>
+        </a:xfrm>
+      </p:grpSpPr>
       <p:sp>
         <p:nvSpPr>
           <p:cNvPr id="2" name="Rectangle 1"/>
@@ -4149,6 +4286,7 @@
           <a:lstStyle/>
           <a:p>
             <a:pPr algn="ctr"/>
+            <a:endParaRPr/>
           </a:p>
         </p:txBody>
       </p:sp>
@@ -4246,7 +4384,7 @@
               </a:spcAft>
             </a:pPr>
             <a:r>
-              <a:rPr sz="1900" b="1">
+              <a:rPr sz="1900" b="1" dirty="0">
                 <a:solidFill>
                   <a:srgbClr val="16213A"/>
                 </a:solidFill>
@@ -4261,7 +4399,7 @@
               </a:spcAft>
             </a:pPr>
             <a:r>
-              <a:rPr sz="1900" b="0">
+              <a:rPr sz="1900" b="0" dirty="0">
                 <a:solidFill>
                   <a:srgbClr val="222838"/>
                 </a:solidFill>
@@ -4276,7 +4414,7 @@
               </a:spcAft>
             </a:pPr>
             <a:r>
-              <a:rPr sz="1900" b="0">
+              <a:rPr sz="1900" b="0" dirty="0">
                 <a:solidFill>
                   <a:srgbClr val="222838"/>
                 </a:solidFill>
@@ -4291,7 +4429,7 @@
               </a:spcAft>
             </a:pPr>
             <a:r>
-              <a:rPr sz="1900" b="0">
+              <a:rPr sz="1900" b="0" dirty="0">
                 <a:solidFill>
                   <a:srgbClr val="222838"/>
                 </a:solidFill>
@@ -4306,7 +4444,7 @@
               </a:spcAft>
             </a:pPr>
             <a:r>
-              <a:rPr sz="1900" b="0">
+              <a:rPr sz="1900" b="0" dirty="0">
                 <a:solidFill>
                   <a:srgbClr val="222838"/>
                 </a:solidFill>

</xml_diff>

<commit_message>
docs(deck): align with final demo — workflows, numbers, roadmap
Nine AI workflows (bilingual + weekly briefing), slide 3 relabeled for
video+live with the star on the screenshot beat, impact numbers match
the current dashboard (88/80/~$11), slide 2 star describes triage at
submission, slide 5 reframed to roadmap, try-it-yourself line added.

Co-Authored-By: Claude Fable 5 <noreply@anthropic.com>
</commit_message>
<xml_diff>
--- a/docs/DECK.pptx
+++ b/docs/DECK.pptx
@@ -306,7 +306,7 @@
           <a:p>
             <a:fld id="{5BCAD085-E8A6-8845-BD4E-CB4CCA059FC4}" type="datetimeFigureOut">
               <a:rPr lang="en-US" smtClean="0"/>
-              <a:t>7/15/2026</a:t>
+              <a:t>7/16/2026</a:t>
             </a:fld>
             <a:endParaRPr lang="en-US"/>
           </a:p>
@@ -474,7 +474,7 @@
           <a:p>
             <a:fld id="{5BCAD085-E8A6-8845-BD4E-CB4CCA059FC4}" type="datetimeFigureOut">
               <a:rPr lang="en-US" smtClean="0"/>
-              <a:t>7/15/2026</a:t>
+              <a:t>7/16/2026</a:t>
             </a:fld>
             <a:endParaRPr lang="en-US"/>
           </a:p>
@@ -652,7 +652,7 @@
           <a:p>
             <a:fld id="{5BCAD085-E8A6-8845-BD4E-CB4CCA059FC4}" type="datetimeFigureOut">
               <a:rPr lang="en-US" smtClean="0"/>
-              <a:t>7/15/2026</a:t>
+              <a:t>7/16/2026</a:t>
             </a:fld>
             <a:endParaRPr lang="en-US"/>
           </a:p>
@@ -820,7 +820,7 @@
           <a:p>
             <a:fld id="{5BCAD085-E8A6-8845-BD4E-CB4CCA059FC4}" type="datetimeFigureOut">
               <a:rPr lang="en-US" smtClean="0"/>
-              <a:t>7/15/2026</a:t>
+              <a:t>7/16/2026</a:t>
             </a:fld>
             <a:endParaRPr lang="en-US"/>
           </a:p>
@@ -1065,7 +1065,7 @@
           <a:p>
             <a:fld id="{5BCAD085-E8A6-8845-BD4E-CB4CCA059FC4}" type="datetimeFigureOut">
               <a:rPr lang="en-US" smtClean="0"/>
-              <a:t>7/15/2026</a:t>
+              <a:t>7/16/2026</a:t>
             </a:fld>
             <a:endParaRPr lang="en-US"/>
           </a:p>
@@ -1350,7 +1350,7 @@
           <a:p>
             <a:fld id="{5BCAD085-E8A6-8845-BD4E-CB4CCA059FC4}" type="datetimeFigureOut">
               <a:rPr lang="en-US" smtClean="0"/>
-              <a:t>7/15/2026</a:t>
+              <a:t>7/16/2026</a:t>
             </a:fld>
             <a:endParaRPr lang="en-US"/>
           </a:p>
@@ -1769,7 +1769,7 @@
           <a:p>
             <a:fld id="{5BCAD085-E8A6-8845-BD4E-CB4CCA059FC4}" type="datetimeFigureOut">
               <a:rPr lang="en-US" smtClean="0"/>
-              <a:t>7/15/2026</a:t>
+              <a:t>7/16/2026</a:t>
             </a:fld>
             <a:endParaRPr lang="en-US"/>
           </a:p>
@@ -1886,7 +1886,7 @@
           <a:p>
             <a:fld id="{5BCAD085-E8A6-8845-BD4E-CB4CCA059FC4}" type="datetimeFigureOut">
               <a:rPr lang="en-US" smtClean="0"/>
-              <a:t>7/15/2026</a:t>
+              <a:t>7/16/2026</a:t>
             </a:fld>
             <a:endParaRPr lang="en-US"/>
           </a:p>
@@ -1981,7 +1981,7 @@
           <a:p>
             <a:fld id="{5BCAD085-E8A6-8845-BD4E-CB4CCA059FC4}" type="datetimeFigureOut">
               <a:rPr lang="en-US" smtClean="0"/>
-              <a:t>7/15/2026</a:t>
+              <a:t>7/16/2026</a:t>
             </a:fld>
             <a:endParaRPr lang="en-US"/>
           </a:p>
@@ -2256,7 +2256,7 @@
           <a:p>
             <a:fld id="{5BCAD085-E8A6-8845-BD4E-CB4CCA059FC4}" type="datetimeFigureOut">
               <a:rPr lang="en-US" smtClean="0"/>
-              <a:t>7/15/2026</a:t>
+              <a:t>7/16/2026</a:t>
             </a:fld>
             <a:endParaRPr lang="en-US"/>
           </a:p>
@@ -2508,7 +2508,7 @@
           <a:p>
             <a:fld id="{5BCAD085-E8A6-8845-BD4E-CB4CCA059FC4}" type="datetimeFigureOut">
               <a:rPr lang="en-US" smtClean="0"/>
-              <a:t>7/15/2026</a:t>
+              <a:t>7/16/2026</a:t>
             </a:fld>
             <a:endParaRPr lang="en-US"/>
           </a:p>
@@ -2719,7 +2719,7 @@
           <a:p>
             <a:fld id="{5BCAD085-E8A6-8845-BD4E-CB4CCA059FC4}" type="datetimeFigureOut">
               <a:rPr lang="en-US" smtClean="0"/>
-              <a:t>7/15/2026</a:t>
+              <a:t>7/16/2026</a:t>
             </a:fld>
             <a:endParaRPr lang="en-US"/>
           </a:p>
@@ -3606,7 +3606,7 @@
                   <a:srgbClr val="16213A"/>
                 </a:solidFill>
               </a:rPr>
-              <a:t>★  One rule: AI does the toil, humans keep authority — every AI decision is confidence-gated, logged, one click to revert</a:t>
+              <a:t>★  Every new ticket is read by AI the moment it lands: category, queue, and priority assigned in seconds — applied automatically above a confidence bar, held for a human below it, every decision logged and one click to revert</a:t>
             </a:r>
           </a:p>
           <a:p>
@@ -3636,7 +3636,7 @@
                   <a:srgbClr val="222838"/>
                 </a:solidFill>
               </a:rPr>
-              <a:t>•  Seven AI workflows on one pipeline: triage (reads screenshots, writes subjects), deflection, outage detection, KB drafting, guided intake, NL search, draft replies</a:t>
+              <a:t>•  Nine AI workflows on one pipeline: triage (reads screenshots, writes subjects), deflection, outage detection, KB drafting, guided intake, bilingual tickets, weekly problem briefing, NL search, draft replies</a:t>
             </a:r>
           </a:p>
           <a:p>
@@ -3819,7 +3819,7 @@
                   <a:srgbClr val="FFFFFF"/>
                 </a:solidFill>
               </a:rPr>
-              <a:t>Five moments from the demo</a:t>
+              <a:t>Five moments — in the video and live to try</a:t>
             </a:r>
           </a:p>
         </p:txBody>
@@ -3852,12 +3852,12 @@
               </a:spcAft>
             </a:pPr>
             <a:r>
-              <a:rPr sz="1900" b="0">
-                <a:solidFill>
-                  <a:srgbClr val="222838"/>
-                </a:solidFill>
-              </a:rPr>
-              <a:t>•  Paste a screenshot, no category, no subject → routed at 97% confidence; the error code was read from the image</a:t>
+              <a:rPr sz="1900" b="1" dirty="0">
+                <a:solidFill>
+                  <a:srgbClr val="16213A"/>
+                </a:solidFill>
+              </a:rPr>
+              <a:t>★  Paste a screenshot, no category, no subject → routed at 97% confidence; the error code was read from the image</a:t>
             </a:r>
           </a:p>
           <a:p>
@@ -3867,12 +3867,12 @@
               </a:spcAft>
             </a:pPr>
             <a:r>
-              <a:rPr sz="1900" b="0">
+              <a:rPr sz="1900" b="0" dirty="0">
                 <a:solidFill>
                   <a:srgbClr val="222838"/>
                 </a:solidFill>
               </a:rPr>
-              <a:t>•  Four “Zoom is down” reports → one incident, company-wide banner, one status change closes them all</a:t>
+              <a:t>•  Three “Zoom is down” reports → one suspected incident, company-wide banner, one status change closes them all — live in one click: the ⚠️ Incident Demo button</a:t>
             </a:r>
           </a:p>
           <a:p>
@@ -3882,12 +3882,20 @@
               </a:spcAft>
             </a:pPr>
             <a:r>
-              <a:rPr sz="1900" b="1">
-                <a:solidFill>
-                  <a:srgbClr val="16213A"/>
-                </a:solidFill>
-              </a:rPr>
-              <a:t>★  “VPN keeps dropping” → SOTO Bot sends the fix; requester replies “solved”; ticket closes with zero agent involvement</a:t>
+              <a:rPr lang="en-US" sz="1900" b="0" dirty="0">
+                <a:solidFill>
+                  <a:srgbClr val="222838"/>
+                </a:solidFill>
+              </a:rPr>
+              <a:t>•  “VP</a:t>
+            </a:r>
+            <a:r>
+              <a:rPr sz="1900" b="0" dirty="0">
+                <a:solidFill>
+                  <a:srgbClr val="222838"/>
+                </a:solidFill>
+              </a:rPr>
+              <a:t>N keeps dropping” → SOTO Bot sends the fix; requester replies “solved”; ticket closes with zero agent involvement</a:t>
             </a:r>
           </a:p>
           <a:p>
@@ -3897,7 +3905,7 @@
               </a:spcAft>
             </a:pPr>
             <a:r>
-              <a:rPr sz="1900" b="0">
+              <a:rPr sz="1900" b="0" dirty="0">
                 <a:solidFill>
                   <a:srgbClr val="222838"/>
                 </a:solidFill>
@@ -3912,7 +3920,7 @@
               </a:spcAft>
             </a:pPr>
             <a:r>
-              <a:rPr sz="1900" b="0">
+              <a:rPr sz="1900" b="0" dirty="0">
                 <a:solidFill>
                   <a:srgbClr val="222838"/>
                 </a:solidFill>
@@ -4138,7 +4146,7 @@
                   <a:srgbClr val="222838"/>
                 </a:solidFill>
               </a:rPr>
-              <a:t>•  AI routing: 87% accuracy · 76% fully automatic — from the audited decision log</a:t>
+              <a:t>•  AI routing: 88% accuracy · 80% fully automatic — from the audited decision log</a:t>
             </a:r>
           </a:p>
           <a:p>
@@ -4153,7 +4161,7 @@
                   <a:srgbClr val="222838"/>
                 </a:solidFill>
               </a:rPr>
-              <a:t>•  AI cost: ~2¢ to triage a ticket; ~$6/month at demo volume — scales linearly</a:t>
+              <a:t>•  AI cost: ~2¢ to triage a ticket; ~$11/month at demo volume — scales linearly</a:t>
             </a:r>
           </a:p>
           <a:p>
@@ -4351,7 +4359,7 @@
                   <a:srgbClr val="FFFFFF"/>
                 </a:solidFill>
               </a:rPr>
-              <a:t>A 30-day pilot, then a CSV upload</a:t>
+              <a:t>What’s next: more AI, less toil</a:t>
             </a:r>
           </a:p>
         </p:txBody>
@@ -4365,7 +4373,7 @@
         <p:spPr>
           <a:xfrm>
             <a:off x="640080" y="1920240"/>
-            <a:ext cx="10881360" cy="4480560"/>
+            <a:ext cx="10881360" cy="3329116"/>
           </a:xfrm>
           <a:prstGeom prst="rect">
             <a:avLst/>
@@ -4389,7 +4397,7 @@
                   <a:srgbClr val="16213A"/>
                 </a:solidFill>
               </a:rPr>
-              <a:t>★  Pilot METS alongside ServiceNow for one queue, 30 days — judged on deflection rate and time-to-resolution</a:t>
+              <a:t>★  On the roadmap: routing that learns from every past resolution, AI-suggested fixes surfaced to agents as they work, and asset tracking tied to tickets</a:t>
             </a:r>
           </a:p>
           <a:p>
@@ -4450,6 +4458,53 @@
                 </a:solidFill>
               </a:rPr>
               <a:t>•  The learning loop compounds — every correction and KB article makes next month better than this one</a:t>
+            </a:r>
+          </a:p>
+          <a:p>
+            <a:pPr>
+              <a:spcAft>
+                <a:spcPts val="1400"/>
+              </a:spcAft>
+            </a:pPr>
+            <a:r>
+              <a:rPr sz="1900" b="0" dirty="0">
+                <a:solidFill>
+                  <a:srgbClr val="222838"/>
+                </a:solidFill>
+              </a:rPr>
+              <a:t>•  Try it yourself during judging:</a:t>
+            </a:r>
+            <a:r>
+              <a:rPr lang="en-US" sz="1900" b="0" dirty="0">
+                <a:solidFill>
+                  <a:srgbClr val="222838"/>
+                </a:solidFill>
+              </a:rPr>
+              <a:t> &lt;</a:t>
+            </a:r>
+            <a:r>
+              <a:rPr lang="en-US" sz="1900" b="0" dirty="0" err="1">
+                <a:solidFill>
+                  <a:srgbClr val="222838"/>
+                </a:solidFill>
+              </a:rPr>
+              <a:t>ip</a:t>
+            </a:r>
+            <a:r>
+              <a:rPr lang="en-US" sz="1900" b="0" dirty="0">
+                <a:solidFill>
+                  <a:srgbClr val="222838"/>
+                </a:solidFill>
+              </a:rPr>
+              <a:t>&gt; </a:t>
+            </a:r>
+            <a:r>
+              <a:rPr sz="1900" b="0" dirty="0">
+                <a:solidFill>
+                  <a:srgbClr val="222838"/>
+                </a:solidFill>
+              </a:rPr>
+              <a:t>— file a ticket, press ⚠️ Incident Demo</a:t>
             </a:r>
           </a:p>
         </p:txBody>

</xml_diff>

<commit_message>
docs(deck): slide 3 highlights bilingual tickets in place of CSV import
Co-Authored-By: Claude Fable 5 <noreply@anthropic.com>
</commit_message>
<xml_diff>
--- a/docs/DECK.pptx
+++ b/docs/DECK.pptx
@@ -306,7 +306,7 @@
           <a:p>
             <a:fld id="{5BCAD085-E8A6-8845-BD4E-CB4CCA059FC4}" type="datetimeFigureOut">
               <a:rPr lang="en-US" smtClean="0"/>
-              <a:t>7/16/2026</a:t>
+              <a:t>7/17/2026</a:t>
             </a:fld>
             <a:endParaRPr lang="en-US"/>
           </a:p>
@@ -474,7 +474,7 @@
           <a:p>
             <a:fld id="{5BCAD085-E8A6-8845-BD4E-CB4CCA059FC4}" type="datetimeFigureOut">
               <a:rPr lang="en-US" smtClean="0"/>
-              <a:t>7/16/2026</a:t>
+              <a:t>7/17/2026</a:t>
             </a:fld>
             <a:endParaRPr lang="en-US"/>
           </a:p>
@@ -652,7 +652,7 @@
           <a:p>
             <a:fld id="{5BCAD085-E8A6-8845-BD4E-CB4CCA059FC4}" type="datetimeFigureOut">
               <a:rPr lang="en-US" smtClean="0"/>
-              <a:t>7/16/2026</a:t>
+              <a:t>7/17/2026</a:t>
             </a:fld>
             <a:endParaRPr lang="en-US"/>
           </a:p>
@@ -820,7 +820,7 @@
           <a:p>
             <a:fld id="{5BCAD085-E8A6-8845-BD4E-CB4CCA059FC4}" type="datetimeFigureOut">
               <a:rPr lang="en-US" smtClean="0"/>
-              <a:t>7/16/2026</a:t>
+              <a:t>7/17/2026</a:t>
             </a:fld>
             <a:endParaRPr lang="en-US"/>
           </a:p>
@@ -1065,7 +1065,7 @@
           <a:p>
             <a:fld id="{5BCAD085-E8A6-8845-BD4E-CB4CCA059FC4}" type="datetimeFigureOut">
               <a:rPr lang="en-US" smtClean="0"/>
-              <a:t>7/16/2026</a:t>
+              <a:t>7/17/2026</a:t>
             </a:fld>
             <a:endParaRPr lang="en-US"/>
           </a:p>
@@ -1350,7 +1350,7 @@
           <a:p>
             <a:fld id="{5BCAD085-E8A6-8845-BD4E-CB4CCA059FC4}" type="datetimeFigureOut">
               <a:rPr lang="en-US" smtClean="0"/>
-              <a:t>7/16/2026</a:t>
+              <a:t>7/17/2026</a:t>
             </a:fld>
             <a:endParaRPr lang="en-US"/>
           </a:p>
@@ -1769,7 +1769,7 @@
           <a:p>
             <a:fld id="{5BCAD085-E8A6-8845-BD4E-CB4CCA059FC4}" type="datetimeFigureOut">
               <a:rPr lang="en-US" smtClean="0"/>
-              <a:t>7/16/2026</a:t>
+              <a:t>7/17/2026</a:t>
             </a:fld>
             <a:endParaRPr lang="en-US"/>
           </a:p>
@@ -1886,7 +1886,7 @@
           <a:p>
             <a:fld id="{5BCAD085-E8A6-8845-BD4E-CB4CCA059FC4}" type="datetimeFigureOut">
               <a:rPr lang="en-US" smtClean="0"/>
-              <a:t>7/16/2026</a:t>
+              <a:t>7/17/2026</a:t>
             </a:fld>
             <a:endParaRPr lang="en-US"/>
           </a:p>
@@ -1981,7 +1981,7 @@
           <a:p>
             <a:fld id="{5BCAD085-E8A6-8845-BD4E-CB4CCA059FC4}" type="datetimeFigureOut">
               <a:rPr lang="en-US" smtClean="0"/>
-              <a:t>7/16/2026</a:t>
+              <a:t>7/17/2026</a:t>
             </a:fld>
             <a:endParaRPr lang="en-US"/>
           </a:p>
@@ -2256,7 +2256,7 @@
           <a:p>
             <a:fld id="{5BCAD085-E8A6-8845-BD4E-CB4CCA059FC4}" type="datetimeFigureOut">
               <a:rPr lang="en-US" smtClean="0"/>
-              <a:t>7/16/2026</a:t>
+              <a:t>7/17/2026</a:t>
             </a:fld>
             <a:endParaRPr lang="en-US"/>
           </a:p>
@@ -2508,7 +2508,7 @@
           <a:p>
             <a:fld id="{5BCAD085-E8A6-8845-BD4E-CB4CCA059FC4}" type="datetimeFigureOut">
               <a:rPr lang="en-US" smtClean="0"/>
-              <a:t>7/16/2026</a:t>
+              <a:t>7/17/2026</a:t>
             </a:fld>
             <a:endParaRPr lang="en-US"/>
           </a:p>
@@ -2719,7 +2719,7 @@
           <a:p>
             <a:fld id="{5BCAD085-E8A6-8845-BD4E-CB4CCA059FC4}" type="datetimeFigureOut">
               <a:rPr lang="en-US" smtClean="0"/>
-              <a:t>7/16/2026</a:t>
+              <a:t>7/17/2026</a:t>
             </a:fld>
             <a:endParaRPr lang="en-US"/>
           </a:p>
@@ -3261,7 +3261,7 @@
         <p:spPr>
           <a:xfrm>
             <a:off x="640080" y="1920240"/>
-            <a:ext cx="10881360" cy="2092881"/>
+            <a:ext cx="9290304" cy="2857192"/>
           </a:xfrm>
           <a:prstGeom prst="rect">
             <a:avLst/>
@@ -3358,6 +3358,31 @@
               </a:rPr>
               <a:t>★  Over 3 years: ~$950k for software that still makes a human read every ticket first</a:t>
             </a:r>
+            <a:endParaRPr lang="en-US" sz="1900" b="1" dirty="0">
+              <a:solidFill>
+                <a:srgbClr val="16213A"/>
+              </a:solidFill>
+            </a:endParaRPr>
+          </a:p>
+          <a:p>
+            <a:pPr>
+              <a:spcAft>
+                <a:spcPts val="1400"/>
+              </a:spcAft>
+            </a:pPr>
+            <a:r>
+              <a:rPr lang="en-US" sz="1900" b="1" dirty="0">
+                <a:solidFill>
+                  <a:srgbClr val="16213A"/>
+                </a:solidFill>
+              </a:rPr>
+              <a:t>							From our ticket intake web portal - 52 different queues! -&gt;</a:t>
+            </a:r>
+            <a:endParaRPr sz="1900" b="1" dirty="0">
+              <a:solidFill>
+                <a:srgbClr val="16213A"/>
+              </a:solidFill>
+            </a:endParaRPr>
           </a:p>
         </p:txBody>
       </p:sp>
@@ -3394,6 +3419,36 @@
           </a:p>
         </p:txBody>
       </p:sp>
+      <p:pic>
+        <p:nvPicPr>
+          <p:cNvPr id="8" name="Picture 7">
+            <a:extLst>
+              <a:ext uri="{FF2B5EF4-FFF2-40B4-BE49-F238E27FC236}">
+                <a16:creationId xmlns:a16="http://schemas.microsoft.com/office/drawing/2014/main" id="{C5D1F0C2-C604-73EE-A48A-E8620675761B}"/>
+              </a:ext>
+            </a:extLst>
+          </p:cNvPr>
+          <p:cNvPicPr>
+            <a:picLocks noChangeAspect="1"/>
+          </p:cNvPicPr>
+          <p:nvPr/>
+        </p:nvPicPr>
+        <p:blipFill>
+          <a:blip r:embed="rId2"/>
+          <a:stretch>
+            <a:fillRect/>
+          </a:stretch>
+        </p:blipFill>
+        <p:spPr>
+          <a:xfrm>
+            <a:off x="10220703" y="0"/>
+            <a:ext cx="1971297" cy="6858000"/>
+          </a:xfrm>
+          <a:prstGeom prst="rect">
+            <a:avLst/>
+          </a:prstGeom>
+        </p:spPr>
+      </p:pic>
     </p:spTree>
   </p:cSld>
   <p:clrMapOvr>
@@ -3538,7 +3593,7 @@
         <p:spPr>
           <a:xfrm>
             <a:off x="640080" y="1920240"/>
-            <a:ext cx="10881360" cy="3149580"/>
+            <a:ext cx="7333488" cy="4411464"/>
           </a:xfrm>
           <a:prstGeom prst="rect">
             <a:avLst/>
@@ -3557,7 +3612,7 @@
               </a:spcAft>
             </a:pPr>
             <a:r>
-              <a:rPr sz="1900" b="0" dirty="0">
+              <a:rPr b="0" dirty="0">
                 <a:solidFill>
                   <a:srgbClr val="222838"/>
                 </a:solidFill>
@@ -3565,7 +3620,7 @@
               <a:t>•  METS </a:t>
             </a:r>
             <a:r>
-              <a:rPr lang="en-US" sz="1900" b="0" dirty="0">
+              <a:rPr lang="en-US" b="0" dirty="0">
                 <a:solidFill>
                   <a:srgbClr val="222838"/>
                 </a:solidFill>
@@ -3573,7 +3628,7 @@
               <a:t>(Master Electronics Ticketing System)</a:t>
             </a:r>
             <a:r>
-              <a:rPr sz="1900" b="0" dirty="0">
+              <a:rPr b="0" dirty="0">
                 <a:solidFill>
                   <a:srgbClr val="222838"/>
                 </a:solidFill>
@@ -3581,14 +3636,14 @@
               <a:t>— built in one week, solo, with Claude Code. AI-native, not AI-bolted-on</a:t>
             </a:r>
             <a:r>
-              <a:rPr lang="en-US" sz="1900" b="0" dirty="0">
+              <a:rPr lang="en-US" b="0" dirty="0">
                 <a:solidFill>
                   <a:srgbClr val="222838"/>
                 </a:solidFill>
               </a:rPr>
               <a:t>.</a:t>
             </a:r>
-            <a:endParaRPr sz="1900" b="0" dirty="0">
+            <a:endParaRPr b="0" dirty="0">
               <a:solidFill>
                 <a:srgbClr val="222838"/>
               </a:solidFill>
@@ -3601,7 +3656,7 @@
               </a:spcAft>
             </a:pPr>
             <a:r>
-              <a:rPr sz="1900" b="1" dirty="0">
+              <a:rPr b="1" dirty="0">
                 <a:solidFill>
                   <a:srgbClr val="16213A"/>
                 </a:solidFill>
@@ -3616,7 +3671,7 @@
               </a:spcAft>
             </a:pPr>
             <a:r>
-              <a:rPr sz="1900" b="0" dirty="0">
+              <a:rPr b="0" dirty="0">
                 <a:solidFill>
                   <a:srgbClr val="222838"/>
                 </a:solidFill>
@@ -3631,7 +3686,7 @@
               </a:spcAft>
             </a:pPr>
             <a:r>
-              <a:rPr sz="1900" b="0" dirty="0">
+              <a:rPr b="0" dirty="0">
                 <a:solidFill>
                   <a:srgbClr val="222838"/>
                 </a:solidFill>
@@ -3646,7 +3701,7 @@
               </a:spcAft>
             </a:pPr>
             <a:r>
-              <a:rPr sz="1900" b="0" dirty="0">
+              <a:rPr b="0" dirty="0">
                 <a:solidFill>
                   <a:srgbClr val="222838"/>
                 </a:solidFill>
@@ -3689,6 +3744,36 @@
           </a:p>
         </p:txBody>
       </p:sp>
+      <p:pic>
+        <p:nvPicPr>
+          <p:cNvPr id="8" name="Picture 7">
+            <a:extLst>
+              <a:ext uri="{FF2B5EF4-FFF2-40B4-BE49-F238E27FC236}">
+                <a16:creationId xmlns:a16="http://schemas.microsoft.com/office/drawing/2014/main" id="{CAE7074C-683B-0A3C-373E-E9E4102BCA89}"/>
+              </a:ext>
+            </a:extLst>
+          </p:cNvPr>
+          <p:cNvPicPr>
+            <a:picLocks noChangeAspect="1"/>
+          </p:cNvPicPr>
+          <p:nvPr/>
+        </p:nvPicPr>
+        <p:blipFill>
+          <a:blip r:embed="rId2"/>
+          <a:stretch>
+            <a:fillRect/>
+          </a:stretch>
+        </p:blipFill>
+        <p:spPr>
+          <a:xfrm>
+            <a:off x="7973568" y="2034540"/>
+            <a:ext cx="4185138" cy="3886200"/>
+          </a:xfrm>
+          <a:prstGeom prst="rect">
+            <a:avLst/>
+          </a:prstGeom>
+        </p:spPr>
+      </p:pic>
     </p:spTree>
   </p:cSld>
   <p:clrMapOvr>
@@ -3833,7 +3918,7 @@
         <p:spPr>
           <a:xfrm>
             <a:off x="640080" y="1920240"/>
-            <a:ext cx="10881360" cy="4480560"/>
+            <a:ext cx="10881360" cy="2534027"/>
           </a:xfrm>
           <a:prstGeom prst="rect">
             <a:avLst/>
@@ -3852,7 +3937,7 @@
               </a:spcAft>
             </a:pPr>
             <a:r>
-              <a:rPr sz="1900" b="1" dirty="0">
+              <a:rPr sz="1600" b="1" dirty="0">
                 <a:solidFill>
                   <a:srgbClr val="16213A"/>
                 </a:solidFill>
@@ -3867,7 +3952,7 @@
               </a:spcAft>
             </a:pPr>
             <a:r>
-              <a:rPr sz="1900" b="0" dirty="0">
+              <a:rPr sz="1600" b="0" dirty="0">
                 <a:solidFill>
                   <a:srgbClr val="222838"/>
                 </a:solidFill>
@@ -3882,7 +3967,7 @@
               </a:spcAft>
             </a:pPr>
             <a:r>
-              <a:rPr lang="en-US" sz="1900" b="0" dirty="0">
+              <a:rPr lang="en-US" sz="1600" b="0" dirty="0">
                 <a:solidFill>
                   <a:srgbClr val="222838"/>
                 </a:solidFill>
@@ -3890,7 +3975,7 @@
               <a:t>•  “VP</a:t>
             </a:r>
             <a:r>
-              <a:rPr sz="1900" b="0" dirty="0">
+              <a:rPr sz="1600" b="0" dirty="0">
                 <a:solidFill>
                   <a:srgbClr val="222838"/>
                 </a:solidFill>
@@ -3905,7 +3990,7 @@
               </a:spcAft>
             </a:pPr>
             <a:r>
-              <a:rPr sz="1900" b="0" dirty="0">
+              <a:rPr sz="1600" b="0" dirty="0">
                 <a:solidFill>
                   <a:srgbClr val="222838"/>
                 </a:solidFill>
@@ -3920,13 +4005,26 @@
               </a:spcAft>
             </a:pPr>
             <a:r>
-              <a:rPr sz="1900" b="0" dirty="0">
+              <a:rPr sz="1600" b="0" dirty="0">
                 <a:solidFill>
                   <a:srgbClr val="222838"/>
                 </a:solidFill>
               </a:rPr>
-              <a:t>•  ServiceNow CSV import — history migrates, original INC numbers stay searchable</a:t>
-            </a:r>
+              <a:t>•  </a:t>
+            </a:r>
+            <a:r>
+              <a:rPr lang="en-US" sz="1600" dirty="0">
+                <a:solidFill>
+                  <a:srgbClr val="222838"/>
+                </a:solidFill>
+              </a:rPr>
+              <a:t>A ticket arrives in Spanish → the agent reads and replies in English; the requester gets it back in Spanish — nobody translates anything</a:t>
+            </a:r>
+            <a:endParaRPr sz="1600" b="0" dirty="0">
+              <a:solidFill>
+                <a:srgbClr val="222838"/>
+              </a:solidFill>
+            </a:endParaRPr>
           </a:p>
         </p:txBody>
       </p:sp>
@@ -3963,6 +4061,36 @@
           </a:p>
         </p:txBody>
       </p:sp>
+      <p:pic>
+        <p:nvPicPr>
+          <p:cNvPr id="10" name="Picture 9">
+            <a:extLst>
+              <a:ext uri="{FF2B5EF4-FFF2-40B4-BE49-F238E27FC236}">
+                <a16:creationId xmlns:a16="http://schemas.microsoft.com/office/drawing/2014/main" id="{791A3886-BEFF-E66C-8391-D778156FC536}"/>
+              </a:ext>
+            </a:extLst>
+          </p:cNvPr>
+          <p:cNvPicPr>
+            <a:picLocks noChangeAspect="1"/>
+          </p:cNvPicPr>
+          <p:nvPr/>
+        </p:nvPicPr>
+        <p:blipFill>
+          <a:blip r:embed="rId2"/>
+          <a:stretch>
+            <a:fillRect/>
+          </a:stretch>
+        </p:blipFill>
+        <p:spPr>
+          <a:xfrm>
+            <a:off x="705360" y="4480395"/>
+            <a:ext cx="9993120" cy="1648055"/>
+          </a:xfrm>
+          <a:prstGeom prst="rect">
+            <a:avLst/>
+          </a:prstGeom>
+        </p:spPr>
+      </p:pic>
     </p:spTree>
   </p:cSld>
   <p:clrMapOvr>
@@ -4107,7 +4235,7 @@
         <p:spPr>
           <a:xfrm>
             <a:off x="640080" y="1920240"/>
-            <a:ext cx="10881360" cy="4480560"/>
+            <a:ext cx="10881360" cy="2272417"/>
           </a:xfrm>
           <a:prstGeom prst="rect">
             <a:avLst/>
@@ -4126,7 +4254,7 @@
               </a:spcAft>
             </a:pPr>
             <a:r>
-              <a:rPr sz="1900" b="1">
+              <a:rPr sz="1900" b="1" dirty="0">
                 <a:solidFill>
                   <a:srgbClr val="16213A"/>
                 </a:solidFill>
@@ -4141,7 +4269,7 @@
               </a:spcAft>
             </a:pPr>
             <a:r>
-              <a:rPr sz="1900" b="0">
+              <a:rPr sz="1900" b="0" dirty="0">
                 <a:solidFill>
                   <a:srgbClr val="222838"/>
                 </a:solidFill>
@@ -4156,12 +4284,44 @@
               </a:spcAft>
             </a:pPr>
             <a:r>
-              <a:rPr sz="1900" b="0">
+              <a:rPr sz="1900" b="0" dirty="0">
                 <a:solidFill>
                   <a:srgbClr val="222838"/>
                 </a:solidFill>
               </a:rPr>
-              <a:t>•  AI cost: ~2¢ to triage a ticket; ~$11/month at demo volume — scales linearly</a:t>
+              <a:t>•  AI cost: ~2</a:t>
+            </a:r>
+            <a:r>
+              <a:rPr lang="en-US" sz="1900" b="0" dirty="0">
+                <a:solidFill>
+                  <a:srgbClr val="222838"/>
+                </a:solidFill>
+              </a:rPr>
+              <a:t>-3</a:t>
+            </a:r>
+            <a:r>
+              <a:rPr sz="1900" b="0" dirty="0">
+                <a:solidFill>
+                  <a:srgbClr val="222838"/>
+                </a:solidFill>
+              </a:rPr>
+              <a:t>¢ to triage a ticket; ~$1</a:t>
+            </a:r>
+            <a:r>
+              <a:rPr lang="en-US" sz="1900" b="0" dirty="0">
+                <a:solidFill>
+                  <a:srgbClr val="222838"/>
+                </a:solidFill>
+              </a:rPr>
+              <a:t>2</a:t>
+            </a:r>
+            <a:r>
+              <a:rPr sz="1900" b="0" dirty="0">
+                <a:solidFill>
+                  <a:srgbClr val="222838"/>
+                </a:solidFill>
+              </a:rPr>
+              <a:t>/month at demo volume — scales linearly</a:t>
             </a:r>
           </a:p>
           <a:p>
@@ -4171,7 +4331,7 @@
               </a:spcAft>
             </a:pPr>
             <a:r>
-              <a:rPr sz="1900" b="0">
+              <a:rPr sz="1900" b="0" dirty="0">
                 <a:solidFill>
                   <a:srgbClr val="222838"/>
                 </a:solidFill>
@@ -4186,12 +4346,28 @@
               </a:spcAft>
             </a:pPr>
             <a:r>
-              <a:rPr sz="1900" b="0">
+              <a:rPr sz="1900" b="0" dirty="0">
                 <a:solidFill>
                   <a:srgbClr val="222838"/>
                 </a:solidFill>
               </a:rPr>
-              <a:t>•  No consultant tax: keywords, SLAs, approvals, VIPs, queues — all live admin settings</a:t>
+              <a:t>• </a:t>
+            </a:r>
+            <a:r>
+              <a:rPr lang="en-US" sz="1900" b="0" dirty="0">
+                <a:solidFill>
+                  <a:srgbClr val="222838"/>
+                </a:solidFill>
+              </a:rPr>
+              <a:t>K</a:t>
+            </a:r>
+            <a:r>
+              <a:rPr sz="1900" b="0" dirty="0">
+                <a:solidFill>
+                  <a:srgbClr val="222838"/>
+                </a:solidFill>
+              </a:rPr>
+              <a:t>eywords, SLAs, approvals, VIPs, queues — all live admin settings</a:t>
             </a:r>
           </a:p>
         </p:txBody>
@@ -4229,6 +4405,66 @@
           </a:p>
         </p:txBody>
       </p:sp>
+      <p:pic>
+        <p:nvPicPr>
+          <p:cNvPr id="8" name="Picture 7">
+            <a:extLst>
+              <a:ext uri="{FF2B5EF4-FFF2-40B4-BE49-F238E27FC236}">
+                <a16:creationId xmlns:a16="http://schemas.microsoft.com/office/drawing/2014/main" id="{ECFE255F-D9C4-1F1D-F488-639AEE8774F3}"/>
+              </a:ext>
+            </a:extLst>
+          </p:cNvPr>
+          <p:cNvPicPr>
+            <a:picLocks noChangeAspect="1"/>
+          </p:cNvPicPr>
+          <p:nvPr/>
+        </p:nvPicPr>
+        <p:blipFill>
+          <a:blip r:embed="rId2"/>
+          <a:stretch>
+            <a:fillRect/>
+          </a:stretch>
+        </p:blipFill>
+        <p:spPr>
+          <a:xfrm>
+            <a:off x="6321541" y="4144175"/>
+            <a:ext cx="5620534" cy="2457793"/>
+          </a:xfrm>
+          <a:prstGeom prst="rect">
+            <a:avLst/>
+          </a:prstGeom>
+        </p:spPr>
+      </p:pic>
+      <p:pic>
+        <p:nvPicPr>
+          <p:cNvPr id="10" name="Picture 9">
+            <a:extLst>
+              <a:ext uri="{FF2B5EF4-FFF2-40B4-BE49-F238E27FC236}">
+                <a16:creationId xmlns:a16="http://schemas.microsoft.com/office/drawing/2014/main" id="{82CC499A-D2F7-6E77-1D16-F0272A43629A}"/>
+              </a:ext>
+            </a:extLst>
+          </p:cNvPr>
+          <p:cNvPicPr>
+            <a:picLocks noChangeAspect="1"/>
+          </p:cNvPicPr>
+          <p:nvPr/>
+        </p:nvPicPr>
+        <p:blipFill>
+          <a:blip r:embed="rId3"/>
+          <a:stretch>
+            <a:fillRect/>
+          </a:stretch>
+        </p:blipFill>
+        <p:spPr>
+          <a:xfrm>
+            <a:off x="984174" y="4944004"/>
+            <a:ext cx="5096586" cy="438211"/>
+          </a:xfrm>
+          <a:prstGeom prst="rect">
+            <a:avLst/>
+          </a:prstGeom>
+        </p:spPr>
+      </p:pic>
     </p:spTree>
   </p:cSld>
   <p:clrMapOvr>
@@ -4480,23 +4716,15 @@
                   <a:srgbClr val="222838"/>
                 </a:solidFill>
               </a:rPr>
-              <a:t> &lt;</a:t>
-            </a:r>
-            <a:r>
-              <a:rPr lang="en-US" sz="1900" b="0" dirty="0" err="1">
+              <a:t> </a:t>
+            </a:r>
+            <a:r>
+              <a:rPr lang="en-US" sz="1900" dirty="0">
                 <a:solidFill>
                   <a:srgbClr val="222838"/>
                 </a:solidFill>
               </a:rPr>
-              <a:t>ip</a:t>
-            </a:r>
-            <a:r>
-              <a:rPr lang="en-US" sz="1900" b="0" dirty="0">
-                <a:solidFill>
-                  <a:srgbClr val="222838"/>
-                </a:solidFill>
-              </a:rPr>
-              <a:t>&gt; </a:t>
+              <a:t>http://10.164.0.235/</a:t>
             </a:r>
             <a:r>
               <a:rPr sz="1900" b="0" dirty="0">

</xml_diff>

<commit_message>
docs(deck): rebuild DECK.pptx from the updated 5-slide story; archive round-1 deck
Slides 2-5 body content rewritten in place (design, screenshots, and
branding preserved; body text at 15pt to carry the denser story):

- Slide 2: ten workflows incl. show-its-work and fix suggestions, plus
  the spends-like-an-engineer line (rules -> mid-tier -> big model ->
  kill switch).
- Slide 3: the five live beats — show-its-work screenshot triage,
  incident (incl. admin Flag -> Escalate), suggest fix with citations,
  Spanish round trip, SOTO-suggested bypass rules. Title now "all of
  them live".
- Slide 4: measured 89% / 78% and the ~1-cent tiered cost story.
- Slide 5: last round's roadmap marked shipped, new roadmap (assets,
  problem mgmt, bilingual portal), no-lock-in line.

Old deck archived as docs/DECK-round1.pptx for reference. Rendered and
QA'd via PowerPoint: no overflow, validator clean.

Co-Authored-By: Claude Fable 5 <noreply@anthropic.com>
</commit_message>
<xml_diff>
--- a/docs/DECK.pptx
+++ b/docs/DECK.pptx
@@ -3608,70 +3608,41 @@
           <a:p>
             <a:pPr>
               <a:spcAft>
-                <a:spcPts val="1400"/>
+                <a:spcPts val="1200"/>
               </a:spcAft>
             </a:pPr>
             <a:r>
-              <a:rPr b="0" dirty="0">
+              <a:rPr sz="1500" b="0" dirty="0">
                 <a:solidFill>
                   <a:srgbClr val="222838"/>
                 </a:solidFill>
               </a:rPr>
-              <a:t>•  METS </a:t>
-            </a:r>
-            <a:r>
-              <a:rPr lang="en-US" b="0" dirty="0">
-                <a:solidFill>
-                  <a:srgbClr val="222838"/>
-                </a:solidFill>
-              </a:rPr>
-              <a:t>(Master Electronics Ticketing System)</a:t>
-            </a:r>
-            <a:r>
-              <a:rPr b="0" dirty="0">
-                <a:solidFill>
-                  <a:srgbClr val="222838"/>
-                </a:solidFill>
-              </a:rPr>
-              <a:t>— built in one week, solo, with Claude Code. AI-native, not AI-bolted-on</a:t>
-            </a:r>
-            <a:r>
-              <a:rPr lang="en-US" b="0" dirty="0">
-                <a:solidFill>
-                  <a:srgbClr val="222838"/>
-                </a:solidFill>
-              </a:rPr>
-              <a:t>.</a:t>
-            </a:r>
-            <a:endParaRPr b="0" dirty="0">
-              <a:solidFill>
-                <a:srgbClr val="222838"/>
-              </a:solidFill>
-            </a:endParaRPr>
+              <a:t>•  Built in one week, solo, with Claude Code — AI-native, not AI-bolted-on, plus the whole helpdesk toolkit: SLAs, approvals, escalations, RBAC, public API, ServiceNow import</a:t>
+            </a:r>
           </a:p>
           <a:p>
             <a:pPr>
               <a:spcAft>
-                <a:spcPts val="1400"/>
+                <a:spcPts val="1200"/>
               </a:spcAft>
             </a:pPr>
             <a:r>
-              <a:rPr b="1" dirty="0">
+              <a:rPr sz="1500" b="1" dirty="0">
                 <a:solidFill>
                   <a:srgbClr val="16213A"/>
                 </a:solidFill>
               </a:rPr>
-              <a:t>★  Every new ticket is read by AI the moment it lands: category, queue, and priority assigned in seconds — applied automatically above a confidence bar, held for a human below it, every decision logged and one click to revert</a:t>
+              <a:t>★  Every ticket is read by AI as it lands: category, queue, priority in seconds — auto-applied above a confidence gate, held for a human below it, every decision logged and one click to revert</a:t>
             </a:r>
           </a:p>
           <a:p>
             <a:pPr>
               <a:spcAft>
-                <a:spcPts val="1400"/>
+                <a:spcPts val="1200"/>
               </a:spcAft>
             </a:pPr>
             <a:r>
-              <a:rPr b="0" dirty="0">
+              <a:rPr sz="1500" b="0" dirty="0">
                 <a:solidFill>
                   <a:srgbClr val="222838"/>
                 </a:solidFill>
@@ -3682,31 +3653,31 @@
           <a:p>
             <a:pPr>
               <a:spcAft>
-                <a:spcPts val="1400"/>
+                <a:spcPts val="1200"/>
               </a:spcAft>
             </a:pPr>
             <a:r>
-              <a:rPr b="0" dirty="0">
+              <a:rPr sz="1500" b="0" dirty="0">
                 <a:solidFill>
                   <a:srgbClr val="222838"/>
                 </a:solidFill>
               </a:rPr>
-              <a:t>•  Nine AI workflows on one pipeline: triage (reads screenshots, writes subjects), deflection, outage detection, KB drafting, guided intake, bilingual tickets, weekly problem briefing, NL search, draft replies</a:t>
+              <a:t>•  Ten AI workflows on one pipeline: triage that reads screenshots and shows its work, deflection, outage detection, KB drafting, fix suggestions from past resolutions, guided intake, bilingual tickets, weekly briefing, NL search, draft replies</a:t>
             </a:r>
           </a:p>
           <a:p>
             <a:pPr>
               <a:spcAft>
-                <a:spcPts val="1400"/>
+                <a:spcPts val="1200"/>
               </a:spcAft>
             </a:pPr>
             <a:r>
-              <a:rPr b="0" dirty="0">
+              <a:rPr sz="1500" b="0" dirty="0">
                 <a:solidFill>
                   <a:srgbClr val="222838"/>
                 </a:solidFill>
               </a:rPr>
-              <a:t>•  And the whole helpdesk toolkit: SLAs, approvals, escalations, RBAC, public API, ServiceNow import</a:t>
+              <a:t>•  It spends like an engineer: rules route deterministic tickets for free (SOTO suggests them itself), a mid-tier model triages the routine, the big model steps in only under the gate — plus a one-click AI kill switch</a:t>
             </a:r>
           </a:p>
         </p:txBody>
@@ -3904,7 +3875,7 @@
                   <a:srgbClr val="FFFFFF"/>
                 </a:solidFill>
               </a:rPr>
-              <a:t>Five moments — in the video and live to try</a:t>
+              <a:t>Five moments — all of them live</a:t>
             </a:r>
           </a:p>
         </p:txBody>
@@ -3933,98 +3904,77 @@
           <a:p>
             <a:pPr>
               <a:spcAft>
-                <a:spcPts val="1400"/>
+                <a:spcPts val="1200"/>
               </a:spcAft>
             </a:pPr>
             <a:r>
-              <a:rPr sz="1600" b="1" dirty="0">
+              <a:rPr sz="1500" b="1" dirty="0">
                 <a:solidFill>
                   <a:srgbClr val="16213A"/>
                 </a:solidFill>
               </a:rPr>
-              <a:t>★  Paste a screenshot, no category, no subject → routed at 97% confidence; the error code was read from the image</a:t>
+              <a:t>★  Paste a screenshot — no category, no subject → SOTO shows its work signal by signal, routes with confidence meters, and writes the subject with the error code read from the image</a:t>
             </a:r>
           </a:p>
           <a:p>
             <a:pPr>
               <a:spcAft>
-                <a:spcPts val="1400"/>
+                <a:spcPts val="1200"/>
               </a:spcAft>
             </a:pPr>
             <a:r>
-              <a:rPr sz="1600" b="0" dirty="0">
+              <a:rPr sz="1500" b="0" dirty="0">
                 <a:solidFill>
                   <a:srgbClr val="222838"/>
                 </a:solidFill>
               </a:rPr>
-              <a:t>•  Three “Zoom is down” reports → one suspected incident, company-wide banner, one status change closes them all — live in one click: the ⚠️ Incident Demo button</a:t>
+              <a:t>•  Three “Zoom is down” reports → one suspected incident, company-wide banner, every requester told “you’re not alone”, one status change closes them all — and admins can Flag → Escalate any ticket instantly, no AI needed</a:t>
             </a:r>
           </a:p>
           <a:p>
             <a:pPr>
               <a:spcAft>
-                <a:spcPts val="1400"/>
+                <a:spcPts val="1200"/>
               </a:spcAft>
             </a:pPr>
             <a:r>
-              <a:rPr lang="en-US" sz="1600" b="0" dirty="0">
+              <a:rPr sz="1500" b="0" dirty="0">
                 <a:solidFill>
                   <a:srgbClr val="222838"/>
                 </a:solidFill>
               </a:rPr>
-              <a:t>•  “VP</a:t>
-            </a:r>
-            <a:r>
-              <a:rPr sz="1600" b="0" dirty="0">
-                <a:solidFill>
-                  <a:srgbClr val="222838"/>
-                </a:solidFill>
-              </a:rPr>
-              <a:t>N keeps dropping” → SOTO Bot sends the fix; requester replies “solved”; ticket closes with zero agent involvement</a:t>
+              <a:t>•  💡 Suggest fix → SOTO proposes the resolution cited from the past tickets that fixed it — 665 resolutions embedded locally as searchable institutional memory, one click to insert into the reply</a:t>
             </a:r>
           </a:p>
           <a:p>
             <a:pPr>
               <a:spcAft>
-                <a:spcPts val="1400"/>
+                <a:spcPts val="1200"/>
               </a:spcAft>
             </a:pPr>
             <a:r>
-              <a:rPr sz="1600" b="0" dirty="0">
+              <a:rPr sz="1500" b="0" dirty="0">
                 <a:solidFill>
                   <a:srgbClr val="222838"/>
                 </a:solidFill>
               </a:rPr>
-              <a:t>•  Databricks access → SOTO asks only what the ticket didn't answer, then routes straight to the Data Team</a:t>
+              <a:t>•  A ticket arrives in Spanish → the agent reads and replies in English; the requester gets it back in Spanish — nobody translates anything</a:t>
             </a:r>
           </a:p>
           <a:p>
             <a:pPr>
               <a:spcAft>
-                <a:spcPts val="1400"/>
+                <a:spcPts val="1200"/>
               </a:spcAft>
             </a:pPr>
             <a:r>
-              <a:rPr sz="1600" b="0" dirty="0">
+              <a:rPr sz="1500" b="0" dirty="0">
                 <a:solidFill>
                   <a:srgbClr val="222838"/>
                 </a:solidFill>
               </a:rPr>
-              <a:t>•  </a:t>
-            </a:r>
-            <a:r>
-              <a:rPr lang="en-US" sz="1600" dirty="0">
-                <a:solidFill>
-                  <a:srgbClr val="222838"/>
-                </a:solidFill>
-              </a:rPr>
-              <a:t>A ticket arrives in Spanish → the agent reads and replies in English; the requester gets it back in Spanish — nobody translates anything</a:t>
-            </a:r>
-            <a:endParaRPr sz="1600" b="0" dirty="0">
-              <a:solidFill>
-                <a:srgbClr val="222838"/>
-              </a:solidFill>
-            </a:endParaRPr>
+              <a:t>•  ✨ SOTO suggests → it notices ticket patterns it keeps routing the same way and proposes bypass rules to stop paying for its own calls</a:t>
+            </a:r>
           </a:p>
         </p:txBody>
       </p:sp>
@@ -4250,11 +4200,11 @@
           <a:p>
             <a:pPr>
               <a:spcAft>
-                <a:spcPts val="1400"/>
+                <a:spcPts val="1200"/>
               </a:spcAft>
             </a:pPr>
             <a:r>
-              <a:rPr sz="1900" b="1" dirty="0">
+              <a:rPr sz="1500" b="1" dirty="0">
                 <a:solidFill>
                   <a:srgbClr val="16213A"/>
                 </a:solidFill>
@@ -4265,73 +4215,41 @@
           <a:p>
             <a:pPr>
               <a:spcAft>
-                <a:spcPts val="1400"/>
+                <a:spcPts val="1200"/>
               </a:spcAft>
             </a:pPr>
             <a:r>
-              <a:rPr sz="1900" b="0" dirty="0">
+              <a:rPr sz="1500" b="0" dirty="0">
                 <a:solidFill>
                   <a:srgbClr val="222838"/>
                 </a:solidFill>
               </a:rPr>
-              <a:t>•  AI routing: 88% accuracy · 80% fully automatic — from the audited decision log</a:t>
+              <a:t>•  AI routing: 89% accuracy · 78% fully automatic — measured from the audited decision log, not projected</a:t>
             </a:r>
           </a:p>
           <a:p>
             <a:pPr>
               <a:spcAft>
-                <a:spcPts val="1400"/>
+                <a:spcPts val="1200"/>
               </a:spcAft>
             </a:pPr>
             <a:r>
-              <a:rPr sz="1900" b="0" dirty="0">
+              <a:rPr sz="1500" b="0" dirty="0">
                 <a:solidFill>
                   <a:srgbClr val="222838"/>
                 </a:solidFill>
               </a:rPr>
-              <a:t>•  AI cost: ~2</a:t>
-            </a:r>
-            <a:r>
-              <a:rPr lang="en-US" sz="1900" b="0" dirty="0">
-                <a:solidFill>
-                  <a:srgbClr val="222838"/>
-                </a:solidFill>
-              </a:rPr>
-              <a:t>-3</a:t>
-            </a:r>
-            <a:r>
-              <a:rPr sz="1900" b="0" dirty="0">
-                <a:solidFill>
-                  <a:srgbClr val="222838"/>
-                </a:solidFill>
-              </a:rPr>
-              <a:t>¢ to triage a ticket; ~$1</a:t>
-            </a:r>
-            <a:r>
-              <a:rPr lang="en-US" sz="1900" b="0" dirty="0">
-                <a:solidFill>
-                  <a:srgbClr val="222838"/>
-                </a:solidFill>
-              </a:rPr>
-              <a:t>2</a:t>
-            </a:r>
-            <a:r>
-              <a:rPr sz="1900" b="0" dirty="0">
-                <a:solidFill>
-                  <a:srgbClr val="222838"/>
-                </a:solidFill>
-              </a:rPr>
-              <a:t>/month at demo volume — scales linearly</a:t>
+              <a:t>•  AI cost: ~1¢ for a typical ticket, $0 for rule-routed ones — tiered models (cheap first, big only under the confidence gate), prompt caching, and self-suggested bypass rules bend the curve down; every call metered per model</a:t>
             </a:r>
           </a:p>
           <a:p>
             <a:pPr>
               <a:spcAft>
-                <a:spcPts val="1400"/>
+                <a:spcPts val="1200"/>
               </a:spcAft>
             </a:pPr>
             <a:r>
-              <a:rPr sz="1900" b="0" dirty="0">
+              <a:rPr sz="1500" b="0" dirty="0">
                 <a:solidFill>
                   <a:srgbClr val="222838"/>
                 </a:solidFill>
@@ -4342,32 +4260,16 @@
           <a:p>
             <a:pPr>
               <a:spcAft>
-                <a:spcPts val="1400"/>
+                <a:spcPts val="1200"/>
               </a:spcAft>
             </a:pPr>
             <a:r>
-              <a:rPr sz="1900" b="0" dirty="0">
+              <a:rPr sz="1500" b="0" dirty="0">
                 <a:solidFill>
                   <a:srgbClr val="222838"/>
                 </a:solidFill>
               </a:rPr>
-              <a:t>• </a:t>
-            </a:r>
-            <a:r>
-              <a:rPr lang="en-US" sz="1900" b="0" dirty="0">
-                <a:solidFill>
-                  <a:srgbClr val="222838"/>
-                </a:solidFill>
-              </a:rPr>
-              <a:t>K</a:t>
-            </a:r>
-            <a:r>
-              <a:rPr sz="1900" b="0" dirty="0">
-                <a:solidFill>
-                  <a:srgbClr val="222838"/>
-                </a:solidFill>
-              </a:rPr>
-              <a:t>eywords, SLAs, approvals, VIPs, queues — all live admin settings</a:t>
+              <a:t>•  No consultant tax: keywords, SLAs, approvals, VIPs, queues, even SOTO’s company knowledge — all live admin settings</a:t>
             </a:r>
           </a:p>
         </p:txBody>
@@ -4624,115 +4526,91 @@
           <a:p>
             <a:pPr>
               <a:spcAft>
-                <a:spcPts val="1400"/>
+                <a:spcPts val="1200"/>
               </a:spcAft>
             </a:pPr>
             <a:r>
-              <a:rPr sz="1900" b="1" dirty="0">
+              <a:rPr sz="1500" b="1" dirty="0">
                 <a:solidFill>
                   <a:srgbClr val="16213A"/>
                 </a:solidFill>
               </a:rPr>
-              <a:t>★  On the roadmap: routing that learns from every past resolution, AI-suggested fixes surfaced to agents as they work, and asset tracking tied to tickets</a:t>
+              <a:t>★  Last round’s roadmap, shipped: similar-ticket grounding and AI-suggested fixes went live this weekend — you just saw them</a:t>
             </a:r>
           </a:p>
           <a:p>
             <a:pPr>
               <a:spcAft>
-                <a:spcPts val="1400"/>
+                <a:spcPts val="1200"/>
               </a:spcAft>
             </a:pPr>
             <a:r>
-              <a:rPr sz="1900" b="0" dirty="0">
+              <a:rPr sz="1500" b="0" dirty="0">
                 <a:solidFill>
                   <a:srgbClr val="222838"/>
                 </a:solidFill>
               </a:rPr>
-              <a:t>•  Two activations, not builds: Entra SSO and mailbox email are written and dormant — one app registration each</a:t>
+              <a:t>•  On the roadmap now: asset tracking tied to tickets, problem management on top of the weekly briefing, a bilingual requester portal (ticket content already translates both ways)</a:t>
             </a:r>
           </a:p>
           <a:p>
             <a:pPr>
               <a:spcAft>
-                <a:spcPts val="1400"/>
+                <a:spcPts val="1200"/>
               </a:spcAft>
             </a:pPr>
             <a:r>
-              <a:rPr sz="1900" b="0" dirty="0">
+              <a:rPr sz="1500" b="0" dirty="0">
                 <a:solidFill>
                   <a:srgbClr val="222838"/>
                 </a:solidFill>
               </a:rPr>
-              <a:t>•  Migration day is a CSV upload: history, numbers, and requesters come along</a:t>
+              <a:t>•  No lock-in: the AI vendor is a plug-in behind one interface — a one-click kill switch drops to keyword rules and the helpdesk keeps running</a:t>
             </a:r>
           </a:p>
           <a:p>
             <a:pPr>
               <a:spcAft>
-                <a:spcPts val="1400"/>
+                <a:spcPts val="1200"/>
               </a:spcAft>
             </a:pPr>
             <a:r>
-              <a:rPr sz="1900" b="0" dirty="0">
+              <a:rPr sz="1500" b="0" dirty="0">
                 <a:solidFill>
                   <a:srgbClr val="222838"/>
                 </a:solidFill>
               </a:rPr>
-              <a:t>•  Honest debt, documented: durable jobs, embedding scale, retention (PROPOSAL.md)</a:t>
+              <a:t>•  Two activations, not builds: Entra SSO and mailbox email are written and dormant — one app registration each; migration day is a CSV upload (history, numbers, requesters come along)</a:t>
             </a:r>
           </a:p>
           <a:p>
             <a:pPr>
               <a:spcAft>
-                <a:spcPts val="1400"/>
+                <a:spcPts val="1200"/>
               </a:spcAft>
             </a:pPr>
             <a:r>
-              <a:rPr sz="1900" b="0" dirty="0">
+              <a:rPr sz="1500" b="0" dirty="0">
                 <a:solidFill>
                   <a:srgbClr val="222838"/>
                 </a:solidFill>
               </a:rPr>
-              <a:t>•  The learning loop compounds — every correction and KB article makes next month better than this one</a:t>
+              <a:t>•  Honest debt, documented (PROPOSAL.md) — and the learning loop compounds: every correction and KB article makes next month better</a:t>
             </a:r>
           </a:p>
           <a:p>
             <a:pPr>
               <a:spcAft>
-                <a:spcPts val="1400"/>
+                <a:spcPts val="1200"/>
               </a:spcAft>
             </a:pPr>
             <a:r>
-              <a:rPr sz="1900" b="0" dirty="0">
+              <a:rPr sz="1500" b="0" dirty="0">
                 <a:solidFill>
                   <a:srgbClr val="222838"/>
                 </a:solidFill>
               </a:rPr>
-              <a:t>•  Try it yourself during judging:</a:t>
-            </a:r>
-            <a:r>
-              <a:rPr lang="en-US" sz="1900" b="0" dirty="0">
-                <a:solidFill>
-                  <a:srgbClr val="222838"/>
-                </a:solidFill>
-              </a:rPr>
-              <a:t> </a:t>
-            </a:r>
-            <a:r>
-              <a:rPr lang="en-US" sz="1900" dirty="0">
-                <a:solidFill>
-                  <a:srgbClr val="222838"/>
-                </a:solidFill>
-              </a:rPr>
-              <a:t>http://10.164.0.235/</a:t>
-            </a:r>
-            <a:r>
-              <a:rPr sz="1900" b="0" dirty="0">
-                <a:solidFill>
-                  <a:srgbClr val="222838"/>
-                </a:solidFill>
-              </a:rPr>
-              <a:t>— file a ticket, press ⚠️ Incident Demo</a:t>
+              <a:t>•  Try it during judging: http://10.164.0.235/ — file a ticket, press ⚠️ Incident Demo</a:t>
             </a:r>
           </a:p>
         </p:txBody>

</xml_diff>

<commit_message>
feat(demo): vision ticket defaults to the real QCerror.png screenshot
demo-tickets.py previously drew a synthetic OMS error unless
--screenshot was passed. The staged vision ticket now defaults to
scripts/QCerror.png (resolved relative to the script, so it works from
any cwd); --screenshot still overrides, and the drawn placeholder only
covers a missing file. Cheat-sheet wording updated to match.

Verified staged: SOTO read the OMS QC URL, workflow header, error
banner, and ITN number off the real image, titled the ticket from it,
and routed to MERP.

Co-Authored-By: Claude Fable 5 <noreply@anthropic.com>
</commit_message>
<xml_diff>
--- a/docs/DECK.pptx
+++ b/docs/DECK.pptx
@@ -306,7 +306,7 @@
           <a:p>
             <a:fld id="{5BCAD085-E8A6-8845-BD4E-CB4CCA059FC4}" type="datetimeFigureOut">
               <a:rPr lang="en-US" smtClean="0"/>
-              <a:t>7/17/2026</a:t>
+              <a:t>7/20/2026</a:t>
             </a:fld>
             <a:endParaRPr lang="en-US"/>
           </a:p>
@@ -474,7 +474,7 @@
           <a:p>
             <a:fld id="{5BCAD085-E8A6-8845-BD4E-CB4CCA059FC4}" type="datetimeFigureOut">
               <a:rPr lang="en-US" smtClean="0"/>
-              <a:t>7/17/2026</a:t>
+              <a:t>7/20/2026</a:t>
             </a:fld>
             <a:endParaRPr lang="en-US"/>
           </a:p>
@@ -652,7 +652,7 @@
           <a:p>
             <a:fld id="{5BCAD085-E8A6-8845-BD4E-CB4CCA059FC4}" type="datetimeFigureOut">
               <a:rPr lang="en-US" smtClean="0"/>
-              <a:t>7/17/2026</a:t>
+              <a:t>7/20/2026</a:t>
             </a:fld>
             <a:endParaRPr lang="en-US"/>
           </a:p>
@@ -820,7 +820,7 @@
           <a:p>
             <a:fld id="{5BCAD085-E8A6-8845-BD4E-CB4CCA059FC4}" type="datetimeFigureOut">
               <a:rPr lang="en-US" smtClean="0"/>
-              <a:t>7/17/2026</a:t>
+              <a:t>7/20/2026</a:t>
             </a:fld>
             <a:endParaRPr lang="en-US"/>
           </a:p>
@@ -1065,7 +1065,7 @@
           <a:p>
             <a:fld id="{5BCAD085-E8A6-8845-BD4E-CB4CCA059FC4}" type="datetimeFigureOut">
               <a:rPr lang="en-US" smtClean="0"/>
-              <a:t>7/17/2026</a:t>
+              <a:t>7/20/2026</a:t>
             </a:fld>
             <a:endParaRPr lang="en-US"/>
           </a:p>
@@ -1350,7 +1350,7 @@
           <a:p>
             <a:fld id="{5BCAD085-E8A6-8845-BD4E-CB4CCA059FC4}" type="datetimeFigureOut">
               <a:rPr lang="en-US" smtClean="0"/>
-              <a:t>7/17/2026</a:t>
+              <a:t>7/20/2026</a:t>
             </a:fld>
             <a:endParaRPr lang="en-US"/>
           </a:p>
@@ -1769,7 +1769,7 @@
           <a:p>
             <a:fld id="{5BCAD085-E8A6-8845-BD4E-CB4CCA059FC4}" type="datetimeFigureOut">
               <a:rPr lang="en-US" smtClean="0"/>
-              <a:t>7/17/2026</a:t>
+              <a:t>7/20/2026</a:t>
             </a:fld>
             <a:endParaRPr lang="en-US"/>
           </a:p>
@@ -1886,7 +1886,7 @@
           <a:p>
             <a:fld id="{5BCAD085-E8A6-8845-BD4E-CB4CCA059FC4}" type="datetimeFigureOut">
               <a:rPr lang="en-US" smtClean="0"/>
-              <a:t>7/17/2026</a:t>
+              <a:t>7/20/2026</a:t>
             </a:fld>
             <a:endParaRPr lang="en-US"/>
           </a:p>
@@ -1981,7 +1981,7 @@
           <a:p>
             <a:fld id="{5BCAD085-E8A6-8845-BD4E-CB4CCA059FC4}" type="datetimeFigureOut">
               <a:rPr lang="en-US" smtClean="0"/>
-              <a:t>7/17/2026</a:t>
+              <a:t>7/20/2026</a:t>
             </a:fld>
             <a:endParaRPr lang="en-US"/>
           </a:p>
@@ -2256,7 +2256,7 @@
           <a:p>
             <a:fld id="{5BCAD085-E8A6-8845-BD4E-CB4CCA059FC4}" type="datetimeFigureOut">
               <a:rPr lang="en-US" smtClean="0"/>
-              <a:t>7/17/2026</a:t>
+              <a:t>7/20/2026</a:t>
             </a:fld>
             <a:endParaRPr lang="en-US"/>
           </a:p>
@@ -2508,7 +2508,7 @@
           <a:p>
             <a:fld id="{5BCAD085-E8A6-8845-BD4E-CB4CCA059FC4}" type="datetimeFigureOut">
               <a:rPr lang="en-US" smtClean="0"/>
-              <a:t>7/17/2026</a:t>
+              <a:t>7/20/2026</a:t>
             </a:fld>
             <a:endParaRPr lang="en-US"/>
           </a:p>
@@ -2719,7 +2719,7 @@
           <a:p>
             <a:fld id="{5BCAD085-E8A6-8845-BD4E-CB4CCA059FC4}" type="datetimeFigureOut">
               <a:rPr lang="en-US" smtClean="0"/>
-              <a:t>7/17/2026</a:t>
+              <a:t>7/20/2026</a:t>
             </a:fld>
             <a:endParaRPr lang="en-US"/>
           </a:p>

</xml_diff>

<commit_message>
docs(deck): add slide 4 - "What a 15-minute demo can't fit"
Two-column grid of 12 features the timed demo never reaches
(deflection, KB auto-drafting, weekly briefing, draft replies,
chat-to-ticket, snooze, API playground, CSV import, recurring
tickets, kill switch + budget cap, merge guard, table stakes),
closing with an invitation to pick one in Q&A. Deck is now 6
slides; kickers renumbered 1/6-6/6. DECK.md mirrors the change
and frames the slide as a ~20-second Q&A menu.

Co-Authored-By: Claude Fable 5 <noreply@anthropic.com>
</commit_message>
<xml_diff>
--- a/docs/DECK.pptx
+++ b/docs/DECK.pptx
@@ -8,8 +8,9 @@
     <p:sldId id="256" r:id="rId2"/>
     <p:sldId id="257" r:id="rId3"/>
     <p:sldId id="258" r:id="rId4"/>
-    <p:sldId id="259" r:id="rId5"/>
-    <p:sldId id="260" r:id="rId6"/>
+    <p:sldId id="261" r:id="rId5"/>
+    <p:sldId id="259" r:id="rId6"/>
+    <p:sldId id="260" r:id="rId7"/>
   </p:sldIdLst>
   <p:sldSz cx="12192000" cy="6858000"/>
   <p:notesSz cx="6858000" cy="9144000"/>
@@ -3214,7 +3215,7 @@
                   <a:srgbClr val="F08A1D"/>
                 </a:solidFill>
               </a:rPr>
-              <a:t>PROBLEM  ·  1/5</a:t>
+              <a:t>PROBLEM  ·  1/6</a:t>
             </a:r>
           </a:p>
         </p:txBody>
@@ -3546,7 +3547,7 @@
                   <a:srgbClr val="F08A1D"/>
                 </a:solidFill>
               </a:rPr>
-              <a:t>APPROACH  ·  2/5</a:t>
+              <a:t>APPROACH  ·  2/6</a:t>
             </a:r>
           </a:p>
         </p:txBody>
@@ -3593,7 +3594,7 @@
         <p:spPr>
           <a:xfrm>
             <a:off x="640080" y="1920240"/>
-            <a:ext cx="7333488" cy="4411464"/>
+            <a:ext cx="7333488" cy="3477875"/>
           </a:xfrm>
           <a:prstGeom prst="rect">
             <a:avLst/>
@@ -3617,7 +3618,23 @@
                   <a:srgbClr val="222838"/>
                 </a:solidFill>
               </a:rPr>
-              <a:t>•  Built in one week, solo, with Claude Code — AI-native, not AI-bolted-on, plus the whole helpdesk toolkit: SLAs, approvals, escalations, RBAC, public API, ServiceNow import</a:t>
+              <a:t>•  </a:t>
+            </a:r>
+            <a:r>
+              <a:rPr lang="en-US" sz="1500" b="0" dirty="0">
+                <a:solidFill>
+                  <a:srgbClr val="222838"/>
+                </a:solidFill>
+              </a:rPr>
+              <a:t>METS (Master Electronics Ticketing System) - </a:t>
+            </a:r>
+            <a:r>
+              <a:rPr sz="1500" b="0" dirty="0">
+                <a:solidFill>
+                  <a:srgbClr val="222838"/>
+                </a:solidFill>
+              </a:rPr>
+              <a:t>Built in one week, solo, with Claude Code — AI-native, not AI-bolted-on, plus the whole helpdesk toolkit: SLAs, approvals, escalations, RBAC, public API, ServiceNow import</a:t>
             </a:r>
           </a:p>
           <a:p>
@@ -3662,7 +3679,23 @@
                   <a:srgbClr val="222838"/>
                 </a:solidFill>
               </a:rPr>
-              <a:t>•  Ten AI workflows on one pipeline: triage that reads screenshots and shows its work, deflection, outage detection, KB drafting, fix suggestions from past resolutions, guided intake, bilingual tickets, weekly briefing, NL search, draft replies</a:t>
+              <a:t>•  Ten AI workflows on one pipeline: triage that reads screenshots and shows its work, deflection, outage detection, KB drafting, fix suggestions from past resolutions, guided intake, bilingual tickets, weekly briefing,</a:t>
+            </a:r>
+            <a:r>
+              <a:rPr lang="en-US" sz="1500" b="0" dirty="0">
+                <a:solidFill>
+                  <a:srgbClr val="222838"/>
+                </a:solidFill>
+              </a:rPr>
+              <a:t> </a:t>
+            </a:r>
+            <a:r>
+              <a:rPr sz="1500" b="0" dirty="0">
+                <a:solidFill>
+                  <a:srgbClr val="222838"/>
+                </a:solidFill>
+              </a:rPr>
+              <a:t>search, draft replies</a:t>
             </a:r>
           </a:p>
           <a:p>
@@ -3677,8 +3710,21 @@
                   <a:srgbClr val="222838"/>
                 </a:solidFill>
               </a:rPr>
-              <a:t>•  It spends like an engineer: rules route deterministic tickets for free (SOTO suggests them itself), a mid-tier model triages the routine, the big model steps in only under the gate — plus a one-click AI kill switch</a:t>
-            </a:r>
+              <a:t>•  It spends like an engineer: rules route deterministic tickets for free (SOTO suggests them itself), a mid-tier model triages the routine, the big model steps in only under the gate</a:t>
+            </a:r>
+            <a:r>
+              <a:rPr lang="en-US" sz="1500" b="0" dirty="0">
+                <a:solidFill>
+                  <a:srgbClr val="222838"/>
+                </a:solidFill>
+              </a:rPr>
+              <a:t>.</a:t>
+            </a:r>
+            <a:endParaRPr sz="1500" b="0" dirty="0">
+              <a:solidFill>
+                <a:srgbClr val="222838"/>
+              </a:solidFill>
+            </a:endParaRPr>
           </a:p>
         </p:txBody>
       </p:sp>
@@ -3842,7 +3888,7 @@
                   <a:srgbClr val="F08A1D"/>
                 </a:solidFill>
               </a:rPr>
-              <a:t>DEMO HIGHLIGHTS  ·  3/5</a:t>
+              <a:t>DEMO HIGHLIGHTS  ·  3/6</a:t>
             </a:r>
           </a:p>
         </p:txBody>
@@ -3856,7 +3902,7 @@
         <p:spPr>
           <a:xfrm>
             <a:off x="640080" y="566928"/>
-            <a:ext cx="10972800" cy="914400"/>
+            <a:ext cx="5852884" cy="584775"/>
           </a:xfrm>
           <a:prstGeom prst="rect">
             <a:avLst/>
@@ -3870,12 +3916,12 @@
           <a:lstStyle/>
           <a:p>
             <a:r>
-              <a:rPr sz="3200" b="1">
+              <a:rPr lang="en-US" sz="3200" b="1" dirty="0">
                 <a:solidFill>
                   <a:srgbClr val="FFFFFF"/>
                 </a:solidFill>
               </a:rPr>
-              <a:t>Five moments — all of them live</a:t>
+              <a:t>Live Demo - http://10.164.0.235/</a:t>
             </a:r>
           </a:p>
         </p:txBody>
@@ -3889,7 +3935,7 @@
         <p:spPr>
           <a:xfrm>
             <a:off x="640080" y="1920240"/>
-            <a:ext cx="10881360" cy="2534027"/>
+            <a:ext cx="10881360" cy="2554545"/>
           </a:xfrm>
           <a:prstGeom prst="rect">
             <a:avLst/>
@@ -4138,7 +4184,7 @@
                   <a:srgbClr val="F08A1D"/>
                 </a:solidFill>
               </a:rPr>
-              <a:t>BUSINESS IMPACT  ·  4/5</a:t>
+              <a:t>ALSO IN THE BOX  ·  4/6</a:t>
             </a:r>
           </a:p>
         </p:txBody>
@@ -4171,7 +4217,7 @@
                   <a:srgbClr val="FFFFFF"/>
                 </a:solidFill>
               </a:rPr>
-              <a:t>The numbers are measured, not projected</a:t>
+              <a:t>What a 15-minute demo can’t fit</a:t>
             </a:r>
           </a:p>
         </p:txBody>
@@ -4184,8 +4230,8 @@
         </p:nvSpPr>
         <p:spPr>
           <a:xfrm>
-            <a:off x="640080" y="1920240"/>
-            <a:ext cx="10881360" cy="2272417"/>
+            <a:off x="640080" y="1874520"/>
+            <a:ext cx="5395000" cy="3900000"/>
           </a:xfrm>
           <a:prstGeom prst="rect">
             <a:avLst/>
@@ -4200,90 +4246,153 @@
           <a:p>
             <a:pPr>
               <a:spcAft>
-                <a:spcPts val="1200"/>
+                <a:spcPts val="1000"/>
               </a:spcAft>
             </a:pPr>
             <a:r>
-              <a:rPr sz="1500" b="1" dirty="0">
+              <a:rPr sz="1400" b="1" dirty="0">
                 <a:solidFill>
                   <a:srgbClr val="16213A"/>
                 </a:solidFill>
               </a:rPr>
-              <a:t>★  ~$210k+/year saved vs the ServiceNow renewal (3-yr TCO: ~$90–320k vs ~$950k)</a:t>
+              <a:t>•  Self-service deflection</a:t>
+            </a:r>
+            <a:r>
+              <a:rPr sz="1400" b="0" dirty="0">
+                <a:solidFill>
+                  <a:srgbClr val="222838"/>
+                </a:solidFill>
+              </a:rPr>
+              <a:t> — SOTO answers from the KB before the ticket is even filed</a:t>
             </a:r>
           </a:p>
           <a:p>
             <a:pPr>
               <a:spcAft>
-                <a:spcPts val="1200"/>
+                <a:spcPts val="1000"/>
               </a:spcAft>
             </a:pPr>
             <a:r>
-              <a:rPr sz="1500" b="0" dirty="0">
+              <a:rPr sz="1400" b="1" dirty="0">
+                <a:solidFill>
+                  <a:srgbClr val="16213A"/>
+                </a:solidFill>
+              </a:rPr>
+              <a:t>•  KB auto-drafting</a:t>
+            </a:r>
+            <a:r>
+              <a:rPr sz="1400" b="0" dirty="0">
                 <a:solidFill>
                   <a:srgbClr val="222838"/>
                 </a:solidFill>
               </a:rPr>
-              <a:t>•  AI routing: 89% accuracy · 78% fully automatic — measured from the audited decision log, not projected</a:t>
+              <a:t> — resolved tickets become draft articles for one-click review, with internal-only visibility control</a:t>
             </a:r>
           </a:p>
           <a:p>
             <a:pPr>
               <a:spcAft>
-                <a:spcPts val="1200"/>
+                <a:spcPts val="1000"/>
               </a:spcAft>
             </a:pPr>
             <a:r>
-              <a:rPr sz="1500" b="0" dirty="0">
+              <a:rPr sz="1400" b="1" dirty="0">
+                <a:solidFill>
+                  <a:srgbClr val="16213A"/>
+                </a:solidFill>
+              </a:rPr>
+              <a:t>•  Weekly problem briefing</a:t>
+            </a:r>
+            <a:r>
+              <a:rPr sz="1400" b="0" dirty="0">
                 <a:solidFill>
                   <a:srgbClr val="222838"/>
                 </a:solidFill>
               </a:rPr>
-              <a:t>•  AI cost: ~1¢ for a typical ticket, $0 for rule-routed ones — tiered models (cheap first, big only under the confidence gate), prompt caching, and self-suggested bypass rules bend the curve down; every call metered per model</a:t>
+              <a:t> — SOTO reads the whole queue and names the recurring problems worth root-causing</a:t>
             </a:r>
           </a:p>
           <a:p>
             <a:pPr>
               <a:spcAft>
-                <a:spcPts val="1200"/>
+                <a:spcPts val="1000"/>
               </a:spcAft>
             </a:pPr>
             <a:r>
-              <a:rPr sz="1500" b="0" dirty="0">
+              <a:rPr sz="1400" b="1" dirty="0">
+                <a:solidFill>
+                  <a:srgbClr val="16213A"/>
+                </a:solidFill>
+              </a:rPr>
+              <a:t>•  Draft replies</a:t>
+            </a:r>
+            <a:r>
+              <a:rPr sz="1400" b="0" dirty="0">
                 <a:solidFill>
                   <a:srgbClr val="222838"/>
                 </a:solidFill>
               </a:rPr>
-              <a:t>•  Self-service deflection + bot first-responses = agent hours back on real work</a:t>
+              <a:t> — grounded in KB articles, edited by the agent, never auto-sent</a:t>
             </a:r>
           </a:p>
           <a:p>
             <a:pPr>
               <a:spcAft>
-                <a:spcPts val="1200"/>
+                <a:spcPts val="1000"/>
               </a:spcAft>
             </a:pPr>
             <a:r>
-              <a:rPr sz="1500" b="0" dirty="0">
+              <a:rPr sz="1400" b="1" dirty="0">
+                <a:solidFill>
+                  <a:srgbClr val="16213A"/>
+                </a:solidFill>
+              </a:rPr>
+              <a:t>•  Agent chat → ticket</a:t>
+            </a:r>
+            <a:r>
+              <a:rPr sz="1400" b="0" dirty="0">
                 <a:solidFill>
                   <a:srgbClr val="222838"/>
                 </a:solidFill>
               </a:rPr>
-              <a:t>•  No consultant tax: keywords, SLAs, approvals, VIPs, queues, even SOTO’s company knowledge — all live admin settings</a:t>
-            </a:r>
-          </a:p>
-        </p:txBody>
-      </p:sp>
-      <p:sp>
-        <p:nvSpPr>
-          <p:cNvPr id="6" name="TextBox 5"/>
+              <a:t> — one click turns a chat thread into a routed ticket; work stops hiding in chat</a:t>
+            </a:r>
+          </a:p>
+          <a:p>
+            <a:pPr>
+              <a:spcAft>
+                <a:spcPts val="1000"/>
+              </a:spcAft>
+            </a:pPr>
+            <a:r>
+              <a:rPr sz="1400" b="1" dirty="0">
+                <a:solidFill>
+                  <a:srgbClr val="16213A"/>
+                </a:solidFill>
+              </a:rPr>
+              <a:t>•  Snooze &amp; scheduled wake</a:t>
+            </a:r>
+            <a:r>
+              <a:rPr sz="1400" b="0" dirty="0">
+                <a:solidFill>
+                  <a:srgbClr val="222838"/>
+                </a:solidFill>
+              </a:rPr>
+              <a:t> — drag to Holding, pick a date; the ticket comes back on its own</a:t>
+            </a:r>
+          </a:p>
+        </p:txBody>
+      </p:sp>
+      <p:sp>
+        <p:nvSpPr>
+          <p:cNvPr id="7" name="TextBox 6"/>
           <p:cNvSpPr txBox="1"/>
           <p:nvPr/>
         </p:nvSpPr>
         <p:spPr>
           <a:xfrm>
-            <a:off x="640080" y="6400800"/>
-            <a:ext cx="10972800" cy="320040"/>
+            <a:off x="6248400" y="1874520"/>
+            <a:ext cx="5395000" cy="3900000"/>
           </a:xfrm>
           <a:prstGeom prst="rect">
             <a:avLst/>
@@ -4291,82 +4400,216 @@
           <a:noFill/>
         </p:spPr>
         <p:txBody>
+          <a:bodyPr wrap="square">
+            <a:spAutoFit/>
+          </a:bodyPr>
+          <a:lstStyle/>
+          <a:p>
+            <a:pPr>
+              <a:spcAft>
+                <a:spcPts val="1000"/>
+              </a:spcAft>
+            </a:pPr>
+            <a:r>
+              <a:rPr sz="1400" b="1" dirty="0">
+                <a:solidFill>
+                  <a:srgbClr val="16213A"/>
+                </a:solidFill>
+              </a:rPr>
+              <a:t>•  Public API + live playground</a:t>
+            </a:r>
+            <a:r>
+              <a:rPr sz="1400" b="0" dirty="0">
+                <a:solidFill>
+                  <a:srgbClr val="222838"/>
+                </a:solidFill>
+              </a:rPr>
+              <a:t> — key-scoped REST API; imported tickets still answer to their old ServiceNow numbers</a:t>
+            </a:r>
+          </a:p>
+          <a:p>
+            <a:pPr>
+              <a:spcAft>
+                <a:spcPts val="1000"/>
+              </a:spcAft>
+            </a:pPr>
+            <a:r>
+              <a:rPr sz="1400" b="1" dirty="0">
+                <a:solidFill>
+                  <a:srgbClr val="16213A"/>
+                </a:solidFill>
+              </a:rPr>
+              <a:t>•  ServiceNow CSV import</a:t>
+            </a:r>
+            <a:r>
+              <a:rPr sz="1400" b="0" dirty="0">
+                <a:solidFill>
+                  <a:srgbClr val="222838"/>
+                </a:solidFill>
+              </a:rPr>
+              <a:t> — history, ticket numbers, and requesters ride along on migration day</a:t>
+            </a:r>
+          </a:p>
+          <a:p>
+            <a:pPr>
+              <a:spcAft>
+                <a:spcPts val="1000"/>
+              </a:spcAft>
+            </a:pPr>
+            <a:r>
+              <a:rPr sz="1400" b="1" dirty="0">
+                <a:solidFill>
+                  <a:srgbClr val="16213A"/>
+                </a:solidFill>
+              </a:rPr>
+              <a:t>•  Recurring tickets</a:t>
+            </a:r>
+            <a:r>
+              <a:rPr sz="1400" b="0" dirty="0">
+                <a:solidFill>
+                  <a:srgbClr val="222838"/>
+                </a:solidFill>
+              </a:rPr>
+              <a:t> — the monthly printer PM files, triages, and routes itself on schedule</a:t>
+            </a:r>
+          </a:p>
+          <a:p>
+            <a:pPr>
+              <a:spcAft>
+                <a:spcPts val="1000"/>
+              </a:spcAft>
+            </a:pPr>
+            <a:r>
+              <a:rPr sz="1400" b="1" dirty="0">
+                <a:solidFill>
+                  <a:srgbClr val="16213A"/>
+                </a:solidFill>
+              </a:rPr>
+              <a:t>•  AI kill switch + daily budget cap</a:t>
+            </a:r>
+            <a:r>
+              <a:rPr sz="1400" b="0" dirty="0">
+                <a:solidFill>
+                  <a:srgbClr val="222838"/>
+                </a:solidFill>
+              </a:rPr>
+              <a:t> — one click degrades to keyword rules; spend can never run away</a:t>
+            </a:r>
+          </a:p>
+          <a:p>
+            <a:pPr>
+              <a:spcAft>
+                <a:spcPts val="1000"/>
+              </a:spcAft>
+            </a:pPr>
+            <a:r>
+              <a:rPr sz="1400" b="1" dirty="0">
+                <a:solidFill>
+                  <a:srgbClr val="16213A"/>
+                </a:solidFill>
+              </a:rPr>
+              <a:t>•  Merge with a part-number guard</a:t>
+            </a:r>
+            <a:r>
+              <a:rPr sz="1400" b="0" dirty="0">
+                <a:solidFill>
+                  <a:srgbClr val="222838"/>
+                </a:solidFill>
+              </a:rPr>
+              <a:t> — similar tickets combine; lookalikes with different part numbers don’t</a:t>
+            </a:r>
+          </a:p>
+          <a:p>
+            <a:pPr>
+              <a:spcAft>
+                <a:spcPts val="1000"/>
+              </a:spcAft>
+            </a:pPr>
+            <a:r>
+              <a:rPr sz="1400" b="1" dirty="0">
+                <a:solidFill>
+                  <a:srgbClr val="16213A"/>
+                </a:solidFill>
+              </a:rPr>
+              <a:t>•  The table stakes, all real</a:t>
+            </a:r>
+            <a:r>
+              <a:rPr sz="1400" b="0" dirty="0">
+                <a:solidFill>
+                  <a:srgbClr val="222838"/>
+                </a:solidFill>
+              </a:rPr>
+              <a:t> — SLAs, approvals, CSAT, VIP scoring, round-robin assign, templates, RBAC, audit trail</a:t>
+            </a:r>
+          </a:p>
+        </p:txBody>
+      </p:sp>
+      <p:sp>
+        <p:nvSpPr>
+          <p:cNvPr id="9" name="TextBox 8"/>
+          <p:cNvSpPr txBox="1"/>
+          <p:nvPr/>
+        </p:nvSpPr>
+        <p:spPr>
+          <a:xfrm>
+            <a:off x="640080" y="5943600"/>
+            <a:ext cx="4100994" cy="307777"/>
+          </a:xfrm>
+          <a:prstGeom prst="rect">
+            <a:avLst/>
+          </a:prstGeom>
+          <a:noFill/>
+        </p:spPr>
+        <p:txBody>
           <a:bodyPr wrap="none">
             <a:spAutoFit/>
           </a:bodyPr>
           <a:lstStyle/>
           <a:p>
             <a:r>
-              <a:rPr sz="1100">
-                <a:solidFill>
-                  <a:srgbClr val="5A647A"/>
-                </a:solidFill>
-              </a:rPr>
-              <a:t>METS — Master Electronics Ticketing System</a:t>
-            </a:r>
-          </a:p>
-        </p:txBody>
-      </p:sp>
-      <p:pic>
-        <p:nvPicPr>
-          <p:cNvPr id="8" name="Picture 7">
-            <a:extLst>
-              <a:ext uri="{FF2B5EF4-FFF2-40B4-BE49-F238E27FC236}">
-                <a16:creationId xmlns:a16="http://schemas.microsoft.com/office/drawing/2014/main" id="{ECFE255F-D9C4-1F1D-F488-639AEE8774F3}"/>
-              </a:ext>
-            </a:extLst>
-          </p:cNvPr>
-          <p:cNvPicPr>
-            <a:picLocks noChangeAspect="1"/>
-          </p:cNvPicPr>
+              <a:rPr sz="1400" b="1" i="1" dirty="0">
+                <a:solidFill>
+                  <a:srgbClr val="F08A1D"/>
+                </a:solidFill>
+              </a:rPr>
+              <a:t>★  Every one of these is running live on this network.</a:t>
+            </a:r>
+          </a:p>
+        </p:txBody>
+      </p:sp>
+      <p:sp>
+        <p:nvSpPr>
+          <p:cNvPr id="6" name="TextBox 5"/>
+          <p:cNvSpPr txBox="1"/>
           <p:nvPr/>
-        </p:nvPicPr>
-        <p:blipFill>
-          <a:blip r:embed="rId2"/>
-          <a:stretch>
-            <a:fillRect/>
-          </a:stretch>
-        </p:blipFill>
-        <p:spPr>
-          <a:xfrm>
-            <a:off x="6321541" y="4144175"/>
-            <a:ext cx="5620534" cy="2457793"/>
+        </p:nvSpPr>
+        <p:spPr>
+          <a:xfrm>
+            <a:off x="640080" y="6400800"/>
+            <a:ext cx="10972800" cy="320040"/>
           </a:xfrm>
           <a:prstGeom prst="rect">
             <a:avLst/>
           </a:prstGeom>
-        </p:spPr>
-      </p:pic>
-      <p:pic>
-        <p:nvPicPr>
-          <p:cNvPr id="10" name="Picture 9">
-            <a:extLst>
-              <a:ext uri="{FF2B5EF4-FFF2-40B4-BE49-F238E27FC236}">
-                <a16:creationId xmlns:a16="http://schemas.microsoft.com/office/drawing/2014/main" id="{82CC499A-D2F7-6E77-1D16-F0272A43629A}"/>
-              </a:ext>
-            </a:extLst>
-          </p:cNvPr>
-          <p:cNvPicPr>
-            <a:picLocks noChangeAspect="1"/>
-          </p:cNvPicPr>
-          <p:nvPr/>
-        </p:nvPicPr>
-        <p:blipFill>
-          <a:blip r:embed="rId3"/>
-          <a:stretch>
-            <a:fillRect/>
-          </a:stretch>
-        </p:blipFill>
-        <p:spPr>
-          <a:xfrm>
-            <a:off x="984174" y="4944004"/>
-            <a:ext cx="5096586" cy="438211"/>
-          </a:xfrm>
-          <a:prstGeom prst="rect">
-            <a:avLst/>
-          </a:prstGeom>
-        </p:spPr>
-      </p:pic>
+          <a:noFill/>
+        </p:spPr>
+        <p:txBody>
+          <a:bodyPr wrap="none">
+            <a:spAutoFit/>
+          </a:bodyPr>
+          <a:lstStyle/>
+          <a:p>
+            <a:r>
+              <a:rPr sz="1100">
+                <a:solidFill>
+                  <a:srgbClr val="5A647A"/>
+                </a:solidFill>
+              </a:rPr>
+              <a:t>METS — Master Electronics Ticketing System</a:t>
+            </a:r>
+          </a:p>
+        </p:txBody>
+      </p:sp>
     </p:spTree>
   </p:cSld>
   <p:clrMapOvr>
@@ -4464,7 +4707,7 @@
                   <a:srgbClr val="F08A1D"/>
                 </a:solidFill>
               </a:rPr>
-              <a:t>WHAT'S NEXT  ·  5/5</a:t>
+              <a:t>BUSINESS IMPACT  ·  5/6</a:t>
             </a:r>
           </a:p>
         </p:txBody>
@@ -4497,7 +4740,7 @@
                   <a:srgbClr val="FFFFFF"/>
                 </a:solidFill>
               </a:rPr>
-              <a:t>What’s next: more AI, less toil</a:t>
+              <a:t>The numbers are measured, not projected</a:t>
             </a:r>
           </a:p>
         </p:txBody>
@@ -4511,7 +4754,7 @@
         <p:spPr>
           <a:xfrm>
             <a:off x="640080" y="1920240"/>
-            <a:ext cx="10881360" cy="3329116"/>
+            <a:ext cx="10881360" cy="2092881"/>
           </a:xfrm>
           <a:prstGeom prst="rect">
             <a:avLst/>
@@ -4535,7 +4778,7 @@
                   <a:srgbClr val="16213A"/>
                 </a:solidFill>
               </a:rPr>
-              <a:t>★  Last round’s roadmap, shipped: similar-ticket grounding and AI-suggested fixes went live this weekend — you just saw them</a:t>
+              <a:t>★  ~$210k+/year saved vs the ServiceNow renewal (3-yr TCO: ~$90–320k vs ~$950k)</a:t>
             </a:r>
           </a:p>
           <a:p>
@@ -4550,7 +4793,7 @@
                   <a:srgbClr val="222838"/>
                 </a:solidFill>
               </a:rPr>
-              <a:t>•  On the roadmap now: asset tracking tied to tickets, problem management on top of the weekly briefing, a bilingual requester portal (ticket content already translates both ways)</a:t>
+              <a:t>•  AI routing: 89% accuracy · 78% fully automatic — measured from the audited decision log, not projected</a:t>
             </a:r>
           </a:p>
           <a:p>
@@ -4565,7 +4808,23 @@
                   <a:srgbClr val="222838"/>
                 </a:solidFill>
               </a:rPr>
-              <a:t>•  No lock-in: the AI vendor is a plug-in behind one interface — a one-click kill switch drops to keyword rules and the helpdesk keeps running</a:t>
+              <a:t>•  AI cost: 1</a:t>
+            </a:r>
+            <a:r>
+              <a:rPr lang="en-US" sz="1500" b="0" dirty="0">
+                <a:solidFill>
+                  <a:srgbClr val="222838"/>
+                </a:solidFill>
+              </a:rPr>
+              <a:t>-3</a:t>
+            </a:r>
+            <a:r>
+              <a:rPr sz="1500" b="0" dirty="0">
+                <a:solidFill>
+                  <a:srgbClr val="222838"/>
+                </a:solidFill>
+              </a:rPr>
+              <a:t>¢ for a typical ticket, $0 for rule-routed ones — tiered models (cheap first, big only under the confidence gate), prompt caching, and self-suggested bypass rules bend the curve down; every call metered per model</a:t>
             </a:r>
           </a:p>
           <a:p>
@@ -4580,7 +4839,7 @@
                   <a:srgbClr val="222838"/>
                 </a:solidFill>
               </a:rPr>
-              <a:t>•  Two activations, not builds: Entra SSO and mailbox email are written and dormant — one app registration each; migration day is a CSV upload (history, numbers, requesters come along)</a:t>
+              <a:t>•  Self-service deflection + bot first-responses = agent hours back on real work</a:t>
             </a:r>
           </a:p>
           <a:p>
@@ -4595,9 +4854,276 @@
                   <a:srgbClr val="222838"/>
                 </a:solidFill>
               </a:rPr>
-              <a:t>•  Honest debt, documented (PROPOSAL.md) — and the learning loop compounds: every correction and KB article makes next month better</a:t>
-            </a:r>
-          </a:p>
+              <a:t>•</a:t>
+            </a:r>
+            <a:r>
+              <a:rPr lang="en-US" sz="1500" b="0" dirty="0">
+                <a:solidFill>
+                  <a:srgbClr val="222838"/>
+                </a:solidFill>
+              </a:rPr>
+              <a:t>  Keywords</a:t>
+            </a:r>
+            <a:r>
+              <a:rPr sz="1500" b="0" dirty="0">
+                <a:solidFill>
+                  <a:srgbClr val="222838"/>
+                </a:solidFill>
+              </a:rPr>
+              <a:t>, SLAs, approvals, VIPs, queues, even SOTO’s company knowledge — all live admin settings</a:t>
+            </a:r>
+          </a:p>
+        </p:txBody>
+      </p:sp>
+      <p:sp>
+        <p:nvSpPr>
+          <p:cNvPr id="6" name="TextBox 5"/>
+          <p:cNvSpPr txBox="1"/>
+          <p:nvPr/>
+        </p:nvSpPr>
+        <p:spPr>
+          <a:xfrm>
+            <a:off x="640080" y="6400800"/>
+            <a:ext cx="10972800" cy="320040"/>
+          </a:xfrm>
+          <a:prstGeom prst="rect">
+            <a:avLst/>
+          </a:prstGeom>
+          <a:noFill/>
+        </p:spPr>
+        <p:txBody>
+          <a:bodyPr wrap="none">
+            <a:spAutoFit/>
+          </a:bodyPr>
+          <a:lstStyle/>
+          <a:p>
+            <a:r>
+              <a:rPr sz="1100">
+                <a:solidFill>
+                  <a:srgbClr val="5A647A"/>
+                </a:solidFill>
+              </a:rPr>
+              <a:t>METS — Master Electronics Ticketing System</a:t>
+            </a:r>
+          </a:p>
+        </p:txBody>
+      </p:sp>
+      <p:pic>
+        <p:nvPicPr>
+          <p:cNvPr id="9" name="Picture 8">
+            <a:extLst>
+              <a:ext uri="{FF2B5EF4-FFF2-40B4-BE49-F238E27FC236}">
+                <a16:creationId xmlns:a16="http://schemas.microsoft.com/office/drawing/2014/main" id="{30CBE1D0-6E2F-5597-0B9B-1EF326FF3AC2}"/>
+              </a:ext>
+            </a:extLst>
+          </p:cNvPr>
+          <p:cNvPicPr>
+            <a:picLocks noChangeAspect="1"/>
+          </p:cNvPicPr>
+          <p:nvPr/>
+        </p:nvPicPr>
+        <p:blipFill>
+          <a:blip r:embed="rId2"/>
+          <a:stretch>
+            <a:fillRect/>
+          </a:stretch>
+        </p:blipFill>
+        <p:spPr>
+          <a:xfrm>
+            <a:off x="877536" y="4963259"/>
+            <a:ext cx="4791744" cy="419158"/>
+          </a:xfrm>
+          <a:prstGeom prst="rect">
+            <a:avLst/>
+          </a:prstGeom>
+        </p:spPr>
+      </p:pic>
+      <p:pic>
+        <p:nvPicPr>
+          <p:cNvPr id="12" name="Picture 11">
+            <a:extLst>
+              <a:ext uri="{FF2B5EF4-FFF2-40B4-BE49-F238E27FC236}">
+                <a16:creationId xmlns:a16="http://schemas.microsoft.com/office/drawing/2014/main" id="{ABAF0040-9F6B-F20B-C6D6-54E94F8A2CD7}"/>
+              </a:ext>
+            </a:extLst>
+          </p:cNvPr>
+          <p:cNvPicPr>
+            <a:picLocks noChangeAspect="1"/>
+          </p:cNvPicPr>
+          <p:nvPr/>
+        </p:nvPicPr>
+        <p:blipFill>
+          <a:blip r:embed="rId3"/>
+          <a:stretch>
+            <a:fillRect/>
+          </a:stretch>
+        </p:blipFill>
+        <p:spPr>
+          <a:xfrm>
+            <a:off x="6095847" y="4063020"/>
+            <a:ext cx="5591955" cy="2638793"/>
+          </a:xfrm>
+          <a:prstGeom prst="rect">
+            <a:avLst/>
+          </a:prstGeom>
+        </p:spPr>
+      </p:pic>
+    </p:spTree>
+  </p:cSld>
+  <p:clrMapOvr>
+    <a:masterClrMapping/>
+  </p:clrMapOvr>
+</p:sld>
+</file>
+
+<file path=ppt/slides/slide6.xml><?xml version="1.0" encoding="utf-8"?>
+<p:sld xmlns:a="http://schemas.openxmlformats.org/drawingml/2006/main" xmlns:r="http://schemas.openxmlformats.org/officeDocument/2006/relationships" xmlns:p="http://schemas.openxmlformats.org/presentationml/2006/main">
+  <p:cSld>
+    <p:spTree>
+      <p:nvGrpSpPr>
+        <p:cNvPr id="1" name=""/>
+        <p:cNvGrpSpPr/>
+        <p:nvPr/>
+      </p:nvGrpSpPr>
+      <p:grpSpPr>
+        <a:xfrm>
+          <a:off x="0" y="0"/>
+          <a:ext cx="0" cy="0"/>
+          <a:chOff x="0" y="0"/>
+          <a:chExt cx="0" cy="0"/>
+        </a:xfrm>
+      </p:grpSpPr>
+      <p:sp>
+        <p:nvSpPr>
+          <p:cNvPr id="2" name="Rectangle 1"/>
+          <p:cNvSpPr/>
+          <p:nvPr/>
+        </p:nvSpPr>
+        <p:spPr>
+          <a:xfrm>
+            <a:off x="0" y="0"/>
+            <a:ext cx="12191695" cy="1554480"/>
+          </a:xfrm>
+          <a:prstGeom prst="rect">
+            <a:avLst/>
+          </a:prstGeom>
+          <a:solidFill>
+            <a:srgbClr val="16213A"/>
+          </a:solidFill>
+          <a:ln>
+            <a:noFill/>
+          </a:ln>
+        </p:spPr>
+        <p:style>
+          <a:lnRef idx="1">
+            <a:schemeClr val="accent1"/>
+          </a:lnRef>
+          <a:fillRef idx="3">
+            <a:schemeClr val="accent1"/>
+          </a:fillRef>
+          <a:effectRef idx="2">
+            <a:schemeClr val="accent1"/>
+          </a:effectRef>
+          <a:fontRef idx="minor">
+            <a:schemeClr val="lt1"/>
+          </a:fontRef>
+        </p:style>
+        <p:txBody>
+          <a:bodyPr rtlCol="0" anchor="ctr"/>
+          <a:lstStyle/>
+          <a:p>
+            <a:pPr algn="ctr"/>
+            <a:endParaRPr/>
+          </a:p>
+        </p:txBody>
+      </p:sp>
+      <p:sp>
+        <p:nvSpPr>
+          <p:cNvPr id="3" name="TextBox 2"/>
+          <p:cNvSpPr txBox="1"/>
+          <p:nvPr/>
+        </p:nvSpPr>
+        <p:spPr>
+          <a:xfrm>
+            <a:off x="640080" y="256032"/>
+            <a:ext cx="10058400" cy="365760"/>
+          </a:xfrm>
+          <a:prstGeom prst="rect">
+            <a:avLst/>
+          </a:prstGeom>
+          <a:noFill/>
+        </p:spPr>
+        <p:txBody>
+          <a:bodyPr wrap="none">
+            <a:spAutoFit/>
+          </a:bodyPr>
+          <a:lstStyle/>
+          <a:p>
+            <a:r>
+              <a:rPr sz="1400" b="1">
+                <a:solidFill>
+                  <a:srgbClr val="F08A1D"/>
+                </a:solidFill>
+              </a:rPr>
+              <a:t>WHAT'S NEXT  ·  6/6</a:t>
+            </a:r>
+          </a:p>
+        </p:txBody>
+      </p:sp>
+      <p:sp>
+        <p:nvSpPr>
+          <p:cNvPr id="4" name="TextBox 3"/>
+          <p:cNvSpPr txBox="1"/>
+          <p:nvPr/>
+        </p:nvSpPr>
+        <p:spPr>
+          <a:xfrm>
+            <a:off x="640080" y="566928"/>
+            <a:ext cx="10972800" cy="914400"/>
+          </a:xfrm>
+          <a:prstGeom prst="rect">
+            <a:avLst/>
+          </a:prstGeom>
+          <a:noFill/>
+        </p:spPr>
+        <p:txBody>
+          <a:bodyPr wrap="none">
+            <a:spAutoFit/>
+          </a:bodyPr>
+          <a:lstStyle/>
+          <a:p>
+            <a:r>
+              <a:rPr sz="3200" b="1">
+                <a:solidFill>
+                  <a:srgbClr val="FFFFFF"/>
+                </a:solidFill>
+              </a:rPr>
+              <a:t>What’s next: more AI, less toil</a:t>
+            </a:r>
+          </a:p>
+        </p:txBody>
+      </p:sp>
+      <p:sp>
+        <p:nvSpPr>
+          <p:cNvPr id="5" name="TextBox 4"/>
+          <p:cNvSpPr txBox="1"/>
+          <p:nvPr/>
+        </p:nvSpPr>
+        <p:spPr>
+          <a:xfrm>
+            <a:off x="640080" y="1920240"/>
+            <a:ext cx="10881360" cy="2400657"/>
+          </a:xfrm>
+          <a:prstGeom prst="rect">
+            <a:avLst/>
+          </a:prstGeom>
+          <a:noFill/>
+        </p:spPr>
+        <p:txBody>
+          <a:bodyPr wrap="square">
+            <a:spAutoFit/>
+          </a:bodyPr>
+          <a:lstStyle/>
           <a:p>
             <a:pPr>
               <a:spcAft>
@@ -4610,7 +5136,52 @@
                   <a:srgbClr val="222838"/>
                 </a:solidFill>
               </a:rPr>
-              <a:t>•  Try it during judging: http://10.164.0.235/ — file a ticket, press ⚠️ Incident Demo</a:t>
+              <a:t>•  On the roadmap now: asset tracking tied to tickets, problem management on top of the weekly briefing, a bilingual requester portal (ticket content already translates both ways)</a:t>
+            </a:r>
+          </a:p>
+          <a:p>
+            <a:pPr>
+              <a:spcAft>
+                <a:spcPts val="1200"/>
+              </a:spcAft>
+            </a:pPr>
+            <a:r>
+              <a:rPr sz="1500" b="0" dirty="0">
+                <a:solidFill>
+                  <a:srgbClr val="222838"/>
+                </a:solidFill>
+              </a:rPr>
+              <a:t>•  No lock-in: the AI vendor is a plug-in behind one interface — a one-click kill switch drops to keyword rules and the helpdesk keeps running</a:t>
+            </a:r>
+          </a:p>
+          <a:p>
+            <a:pPr>
+              <a:spcAft>
+                <a:spcPts val="1200"/>
+              </a:spcAft>
+            </a:pPr>
+            <a:r>
+              <a:rPr sz="1500" b="0" dirty="0">
+                <a:solidFill>
+                  <a:srgbClr val="222838"/>
+                </a:solidFill>
+              </a:rPr>
+              <a:t>•  Two activations, not builds: Entra SSO and mailbox email are written and dormant — one app registration each; migration day is a CSV upload (history, numbers, requesters come along)</a:t>
+            </a:r>
+          </a:p>
+          <a:p>
+            <a:pPr>
+              <a:spcAft>
+                <a:spcPts val="1200"/>
+              </a:spcAft>
+            </a:pPr>
+            <a:r>
+              <a:rPr sz="1500" b="0" dirty="0">
+                <a:solidFill>
+                  <a:srgbClr val="222838"/>
+                </a:solidFill>
+              </a:rPr>
+              <a:t>•  Honest debt, documented (PROPOSAL.md) — and the learning loop compounds: every correction and KB article makes next month better</a:t>
             </a:r>
           </a:p>
         </p:txBody>

</xml_diff>